<commit_message>
Fill in student and guide details on title slide
Co-Authored-By: Claude Opus 5.5 <noreply@anthropic.com>
Claude-Session: https://claude.ai/code/session_01UWkkDpo8nEEYXAoEYMWQqa
</commit_message>
<xml_diff>
--- a/presentation/Virtual_Influencers_Trust_Purchase_Intention_GenZ.pptx
+++ b/presentation/Virtual_Influencers_Trust_Purchase_Intention_GenZ.pptx
@@ -124,14 +124,14 @@
   <p:extLst>
     <p:ext uri="{521415D9-36F7-43E2-AB2F-B90AF26B5E84}">
       <p14:sectionLst xmlns:p14="http://schemas.microsoft.com/office/powerpoint/2010/main">
-        <p14:section name="Introduction" id="{9068d7f6-2215-31ab-6459-87d3eb2c0b0f}">
+        <p14:section name="Introduction" id="{3f09e63e-2196-5ce3-0849-e891f9b8d865}">
           <p14:sldIdLst>
             <p14:sldId id="256"/>
             <p14:sldId id="257"/>
             <p14:sldId id="258"/>
           </p14:sldIdLst>
         </p14:section>
-        <p14:section name="Literature Review" id="{9c3a6d1e-663f-f5e4-a45f-e4b5d20ed35d}">
+        <p14:section name="Literature Review" id="{ed3ba60d-8abd-1234-3b6e-6189905dcd64}">
           <p14:sldIdLst>
             <p14:sldId id="259"/>
             <p14:sldId id="260"/>
@@ -142,7 +142,7 @@
             <p14:sldId id="265"/>
           </p14:sldIdLst>
         </p14:section>
-        <p14:section name="Research Design" id="{e456c493-f848-9cd7-d9b6-7b86fc4fda3c}">
+        <p14:section name="Research Design" id="{197add1f-4c5d-ea0e-ecba-1b0ddfa77f25}">
           <p14:sldIdLst>
             <p14:sldId id="266"/>
             <p14:sldId id="267"/>
@@ -151,7 +151,7 @@
             <p14:sldId id="270"/>
           </p14:sldIdLst>
         </p14:section>
-        <p14:section name="References" id="{09ddfb53-0d03-9af0-b97d-728c7a1a2b2c}">
+        <p14:section name="References" id="{a3d8a4d4-dc5b-125c-d894-93aa50b97e58}">
           <p14:sldIdLst>
             <p14:sldId id="271"/>
             <p14:sldId id="272"/>
@@ -2896,7 +2896,7 @@
                   <a:srgbClr val="000000"/>
                 </a:solidFill>
               </a:rPr>
-              <a:t>[Guide Name]</a:t>
+              <a:t>Dr. Mithra Manmadhan</a:t>
             </a:r>
             <a:endParaRPr lang="en-US" sz="1800" dirty="0"/>
           </a:p>
@@ -2910,7 +2910,7 @@
                   <a:srgbClr val="000000"/>
                 </a:solidFill>
               </a:rPr>
-              <a:t>[Designation]</a:t>
+              <a:t>Assistant Professor</a:t>
             </a:r>
             <a:endParaRPr lang="en-US" sz="1800" dirty="0"/>
           </a:p>
@@ -2946,7 +2946,7 @@
                   <a:srgbClr val="000000"/>
                 </a:solidFill>
               </a:rPr>
-              <a:t>[Your Name]</a:t>
+              <a:t>Abhiram JP</a:t>
             </a:r>
             <a:endParaRPr lang="en-US" sz="1800" dirty="0"/>
           </a:p>
@@ -2960,7 +2960,7 @@
                   <a:srgbClr val="000000"/>
                 </a:solidFill>
               </a:rPr>
-              <a:t>[MBA Batch]</a:t>
+              <a:t>MBA Batch B</a:t>
             </a:r>
             <a:endParaRPr lang="en-US" sz="1800" dirty="0"/>
           </a:p>
@@ -2974,7 +2974,7 @@
                   <a:srgbClr val="000000"/>
                 </a:solidFill>
               </a:rPr>
-              <a:t>[Register Number]</a:t>
+              <a:t>TVE25MBA03</a:t>
             </a:r>
             <a:endParaRPr lang="en-US" sz="1800" dirty="0"/>
           </a:p>

</xml_diff>

<commit_message>
Remove methodology slide not based on provided content
Co-Authored-By: Claude Opus 5.5 <noreply@anthropic.com>
Claude-Session: https://claude.ai/code/session_01UWkkDpo8nEEYXAoEYMWQqa
</commit_message>
<xml_diff>
--- a/presentation/Virtual_Influencers_Trust_Purchase_Intention_GenZ.pptx
+++ b/presentation/Virtual_Influencers_Trust_Purchase_Intention_GenZ.pptx
@@ -22,10 +22,9 @@
     <p:sldId id="270" r:id="rId16"/>
     <p:sldId id="271" r:id="rId17"/>
     <p:sldId id="272" r:id="rId18"/>
-    <p:sldId id="273" r:id="rId19"/>
   </p:sldIdLst>
   <p:notesMasterIdLst>
-    <p:notesMasterId r:id="rId20"/>
+    <p:notesMasterId r:id="rId19"/>
   </p:notesMasterIdLst>
   <p:sldSz cx="12192000" cy="6858000"/>
   <p:notesSz cx="6858000" cy="12192000"/>
@@ -124,14 +123,14 @@
   <p:extLst>
     <p:ext uri="{521415D9-36F7-43E2-AB2F-B90AF26B5E84}">
       <p14:sectionLst xmlns:p14="http://schemas.microsoft.com/office/powerpoint/2010/main">
-        <p14:section name="Introduction" id="{3f09e63e-2196-5ce3-0849-e891f9b8d865}">
+        <p14:section name="Introduction" id="{9ce611fe-accb-3d45-fb98-522340e914d3}">
           <p14:sldIdLst>
             <p14:sldId id="256"/>
             <p14:sldId id="257"/>
             <p14:sldId id="258"/>
           </p14:sldIdLst>
         </p14:section>
-        <p14:section name="Literature Review" id="{ed3ba60d-8abd-1234-3b6e-6189905dcd64}">
+        <p14:section name="Literature Review" id="{feaa6dcf-657f-879d-5573-3a3d525dfc1e}">
           <p14:sldIdLst>
             <p14:sldId id="259"/>
             <p14:sldId id="260"/>
@@ -142,20 +141,19 @@
             <p14:sldId id="265"/>
           </p14:sldIdLst>
         </p14:section>
-        <p14:section name="Research Design" id="{197add1f-4c5d-ea0e-ecba-1b0ddfa77f25}">
+        <p14:section name="Research Design" id="{2336ccdf-7c2b-db74-3987-5b66b37266b9}">
           <p14:sldIdLst>
             <p14:sldId id="266"/>
             <p14:sldId id="267"/>
             <p14:sldId id="268"/>
             <p14:sldId id="269"/>
-            <p14:sldId id="270"/>
           </p14:sldIdLst>
         </p14:section>
-        <p14:section name="References" id="{a3d8a4d4-dc5b-125c-d894-93aa50b97e58}">
+        <p14:section name="References" id="{57a43cbe-4a9b-992a-b218-e9170f869ea3}">
           <p14:sldIdLst>
+            <p14:sldId id="270"/>
             <p14:sldId id="271"/>
             <p14:sldId id="272"/>
-            <p14:sldId id="273"/>
           </p14:sldIdLst>
         </p14:section>
       </p14:sectionLst>
@@ -1290,94 +1288,6 @@
             <a:fld id="{F7021451-1387-4CA6-816F-3879F97B5CBC}" type="slidenum">
               <a:rPr lang="en-US"/>
               <a:t>17</a:t>
-            </a:fld>
-            <a:endParaRPr lang="en-US"/>
-          </a:p>
-        </p:txBody>
-      </p:sp>
-    </p:spTree>
-    <p:extLst>
-      <p:ext uri="{BB962C8B-B14F-4D97-AF65-F5344CB8AC3E}">
-        <p14:creationId xmlns:p14="http://schemas.microsoft.com/office/powerpoint/2010/main" val="1024086991"/>
-      </p:ext>
-    </p:extLst>
-  </p:cSld>
-  <p:clrMapOvr>
-    <a:masterClrMapping/>
-  </p:clrMapOvr>
-</p:notes>
-</file>
-
-<file path=ppt/notesSlides/notesSlide18.xml><?xml version="1.0" encoding="utf-8"?>
-<p:notes xmlns:a="http://schemas.openxmlformats.org/drawingml/2006/main" xmlns:r="http://schemas.openxmlformats.org/officeDocument/2006/relationships" xmlns:p="http://schemas.openxmlformats.org/presentationml/2006/main">
-  <p:cSld>
-    <p:spTree>
-      <p:nvGrpSpPr>
-        <p:cNvPr id="1" name=""/>
-        <p:cNvGrpSpPr/>
-        <p:nvPr/>
-      </p:nvGrpSpPr>
-      <p:grpSpPr>
-        <a:xfrm>
-          <a:off x="0" y="0"/>
-          <a:ext cx="0" cy="0"/>
-          <a:chOff x="0" y="0"/>
-          <a:chExt cx="0" cy="0"/>
-        </a:xfrm>
-      </p:grpSpPr>
-      <p:sp>
-        <p:nvSpPr>
-          <p:cNvPr id="2" name="Slide Image Placeholder 1"/>
-          <p:cNvSpPr>
-            <a:spLocks noGrp="1" noRot="1" noChangeAspect="1"/>
-          </p:cNvSpPr>
-          <p:nvPr>
-            <p:ph type="sldImg"/>
-          </p:nvPr>
-        </p:nvSpPr>
-        <p:spPr/>
-      </p:sp>
-      <p:sp>
-        <p:nvSpPr>
-          <p:cNvPr id="3" name="Notes Placeholder 2"/>
-          <p:cNvSpPr>
-            <a:spLocks noGrp="1"/>
-          </p:cNvSpPr>
-          <p:nvPr>
-            <p:ph type="body" idx="1"/>
-          </p:nvPr>
-        </p:nvSpPr>
-        <p:spPr/>
-        <p:txBody>
-          <a:bodyPr/>
-          <a:lstStyle/>
-          <a:p>
-            <a:r>
-              <a:rPr lang="en-US" dirty="0"/>
-              <a:t/>
-            </a:r>
-            <a:endParaRPr lang="en-US" dirty="0"/>
-          </a:p>
-        </p:txBody>
-      </p:sp>
-      <p:sp>
-        <p:nvSpPr>
-          <p:cNvPr id="4" name="Slide Number Placeholder 3"/>
-          <p:cNvSpPr>
-            <a:spLocks noGrp="1"/>
-          </p:cNvSpPr>
-          <p:nvPr>
-            <p:ph type="sldNum" sz="quarter" idx="10"/>
-          </p:nvPr>
-        </p:nvSpPr>
-        <p:spPr/>
-        <p:txBody>
-          <a:bodyPr/>
-          <a:lstStyle/>
-          <a:p>
-            <a:fld id="{F7021451-1387-4CA6-816F-3879F97B5CBC}" type="slidenum">
-              <a:rPr lang="en-US"/>
-              <a:t>18</a:t>
             </a:fld>
             <a:endParaRPr lang="en-US"/>
           </a:p>
@@ -7107,7 +7017,7 @@
                   <a:schemeClr val="tx1"/>
                 </a:solidFill>
               </a:rPr>
-              <a:t>RESEARCH METHODOLOGY</a:t>
+              <a:t>REFERENCES (SELECTED)</a:t>
             </a:r>
             <a:endParaRPr lang="en-US" sz="2600" dirty="0"/>
           </a:p>
@@ -7115,88 +7025,14 @@
       </p:sp>
       <p:sp>
         <p:nvSpPr>
-          <p:cNvPr id="3" name="Research design card"/>
-          <p:cNvSpPr/>
-          <p:nvPr/>
-        </p:nvSpPr>
-        <p:spPr>
-          <a:xfrm>
-            <a:off x="548640" y="1600200"/>
-            <a:ext cx="3538728" cy="2148840"/>
-          </a:xfrm>
-          <a:prstGeom prst="rect">
-            <a:avLst/>
-          </a:prstGeom>
-          <a:solidFill>
-            <a:schemeClr val="bg2"/>
-          </a:solidFill>
-          <a:ln w="12700">
-            <a:solidFill>
-              <a:schemeClr val="bg2"/>
-            </a:solidFill>
-            <a:prstDash val="solid"/>
-          </a:ln>
-        </p:spPr>
-      </p:sp>
-      <p:sp>
-        <p:nvSpPr>
-          <p:cNvPr id="4" name="Research design circle"/>
-          <p:cNvSpPr/>
-          <p:nvPr/>
-        </p:nvSpPr>
-        <p:spPr>
-          <a:xfrm>
-            <a:off x="731520" y="1783080"/>
-            <a:ext cx="548640" cy="548640"/>
-          </a:xfrm>
-          <a:prstGeom prst="ellipse">
-            <a:avLst/>
-          </a:prstGeom>
-          <a:solidFill>
-            <a:schemeClr val="tx2"/>
-          </a:solidFill>
-          <a:ln w="12700">
-            <a:solidFill>
-              <a:schemeClr val="tx2"/>
-            </a:solidFill>
-            <a:prstDash val="solid"/>
-          </a:ln>
-        </p:spPr>
-      </p:sp>
-      <p:pic>
-        <p:nvPicPr>
-          <p:cNvPr id="5" name="Research design icon" descr="preencoded.png">    </p:cNvPr>
-          <p:cNvPicPr>
-            <a:picLocks noChangeAspect="1"/>
-          </p:cNvPicPr>
-          <p:nvPr/>
-        </p:nvPicPr>
-        <p:blipFill>
-          <a:blip r:embed="rId1"/>
-          <a:stretch>
-            <a:fillRect/>
-          </a:stretch>
-        </p:blipFill>
-        <p:spPr>
-          <a:xfrm>
-            <a:off x="868680" y="1920240"/>
-            <a:ext cx="274320" cy="274320"/>
-          </a:xfrm>
-          <a:prstGeom prst="rect">
-            <a:avLst/>
-          </a:prstGeom>
-        </p:spPr>
-      </p:pic>
-      <p:sp>
-        <p:nvSpPr>
-          <p:cNvPr id="6" name="Text 3"/>
+          <p:cNvPr id="3" name="Text 1"/>
           <p:cNvSpPr txBox="1"/>
           <p:nvPr/>
         </p:nvSpPr>
         <p:spPr>
           <a:xfrm>
-            <a:off x="1417320" y="1783080"/>
-            <a:ext cx="2560320" cy="548640"/>
+            <a:off x="548640" y="1554480"/>
+            <a:ext cx="11091672" cy="4846320"/>
           </a:xfrm>
           <a:prstGeom prst="rect">
             <a:avLst/>
@@ -7205,787 +7041,177 @@
           <a:ln/>
         </p:spPr>
         <p:txBody>
-          <a:bodyPr wrap="square" lIns="0" tIns="0" rIns="0" bIns="0" rtlCol="0" anchor="ctr"/>
-          <a:lstStyle/>
-          <a:p>
-            <a:pPr indent="0" marL="0">
-              <a:buNone/>
-            </a:pPr>
-            <a:r>
-              <a:rPr lang="en-US" sz="1700" b="1" dirty="0">
-                <a:solidFill>
-                  <a:schemeClr val="tx1"/>
-                </a:solidFill>
-              </a:rPr>
-              <a:t>Research design</a:t>
-            </a:r>
-            <a:endParaRPr lang="en-US" sz="1700" dirty="0"/>
-          </a:p>
-        </p:txBody>
-      </p:sp>
-      <p:sp>
-        <p:nvSpPr>
-          <p:cNvPr id="7" name="Text 4"/>
-          <p:cNvSpPr txBox="1"/>
-          <p:nvPr/>
-        </p:nvSpPr>
-        <p:spPr>
-          <a:xfrm>
-            <a:off x="731520" y="2468880"/>
-            <a:ext cx="3200400" cy="1188720"/>
-          </a:xfrm>
-          <a:prstGeom prst="rect">
-            <a:avLst/>
-          </a:prstGeom>
-          <a:noFill/>
-          <a:ln/>
-        </p:spPr>
-        <p:txBody>
           <a:bodyPr wrap="square" lIns="0" tIns="0" rIns="0" bIns="0" rtlCol="0" anchor="t"/>
           <a:lstStyle/>
           <a:p>
             <a:pPr indent="0" marL="0">
-              <a:buNone/>
-            </a:pPr>
-            <a:r>
-              <a:rPr lang="en-US" sz="1400" dirty="0">
-                <a:solidFill>
-                  <a:schemeClr val="tx2"/>
-                </a:solidFill>
-              </a:rPr>
-              <a:t>Descriptive, quantitative, cross-sectional survey</a:t>
-            </a:r>
-            <a:endParaRPr lang="en-US" sz="1400" dirty="0"/>
-          </a:p>
-        </p:txBody>
-      </p:sp>
-      <p:sp>
-        <p:nvSpPr>
-          <p:cNvPr id="8" name="Population card"/>
-          <p:cNvSpPr/>
-          <p:nvPr/>
-        </p:nvSpPr>
-        <p:spPr>
-          <a:xfrm>
-            <a:off x="4325112" y="1600200"/>
-            <a:ext cx="3538728" cy="2148840"/>
-          </a:xfrm>
-          <a:prstGeom prst="rect">
-            <a:avLst/>
-          </a:prstGeom>
-          <a:solidFill>
-            <a:schemeClr val="bg2"/>
-          </a:solidFill>
-          <a:ln w="12700">
-            <a:solidFill>
-              <a:schemeClr val="bg2"/>
-            </a:solidFill>
-            <a:prstDash val="solid"/>
-          </a:ln>
-        </p:spPr>
-      </p:sp>
-      <p:sp>
-        <p:nvSpPr>
-          <p:cNvPr id="9" name="Population circle"/>
-          <p:cNvSpPr/>
-          <p:nvPr/>
-        </p:nvSpPr>
-        <p:spPr>
-          <a:xfrm>
-            <a:off x="4507992" y="1783080"/>
-            <a:ext cx="548640" cy="548640"/>
-          </a:xfrm>
-          <a:prstGeom prst="ellipse">
-            <a:avLst/>
-          </a:prstGeom>
-          <a:solidFill>
-            <a:schemeClr val="accent1"/>
-          </a:solidFill>
-          <a:ln w="12700">
-            <a:solidFill>
-              <a:schemeClr val="accent1"/>
-            </a:solidFill>
-            <a:prstDash val="solid"/>
-          </a:ln>
-        </p:spPr>
-      </p:sp>
-      <p:pic>
-        <p:nvPicPr>
-          <p:cNvPr id="10" name="Population icon" descr="preencoded.png">    </p:cNvPr>
-          <p:cNvPicPr>
-            <a:picLocks noChangeAspect="1"/>
-          </p:cNvPicPr>
-          <p:nvPr/>
-        </p:nvPicPr>
-        <p:blipFill>
-          <a:blip r:embed="rId2"/>
-          <a:stretch>
-            <a:fillRect/>
-          </a:stretch>
-        </p:blipFill>
-        <p:spPr>
-          <a:xfrm>
-            <a:off x="4645152" y="1920240"/>
-            <a:ext cx="274320" cy="274320"/>
-          </a:xfrm>
-          <a:prstGeom prst="rect">
-            <a:avLst/>
-          </a:prstGeom>
-        </p:spPr>
-      </p:pic>
-      <p:sp>
-        <p:nvSpPr>
-          <p:cNvPr id="11" name="Text 7"/>
-          <p:cNvSpPr txBox="1"/>
-          <p:nvPr/>
-        </p:nvSpPr>
-        <p:spPr>
-          <a:xfrm>
-            <a:off x="5193792" y="1783080"/>
-            <a:ext cx="2560320" cy="548640"/>
-          </a:xfrm>
-          <a:prstGeom prst="rect">
-            <a:avLst/>
-          </a:prstGeom>
-          <a:noFill/>
-          <a:ln/>
-        </p:spPr>
-        <p:txBody>
-          <a:bodyPr wrap="square" lIns="0" tIns="0" rIns="0" bIns="0" rtlCol="0" anchor="ctr"/>
-          <a:lstStyle/>
+              <a:spcAft>
+                <a:spcPts val="600"/>
+              </a:spcAft>
+              <a:buNone/>
+            </a:pPr>
+            <a:r>
+              <a:rPr lang="en-US" sz="1200" dirty="0">
+                <a:solidFill>
+                  <a:schemeClr val="tx1"/>
+                </a:solidFill>
+              </a:rPr>
+              <a:t>Allal-Chérif, O., Puertas, R., &amp; Carracedo, P. (2024). Intelligent influencer marketing: How AI-powered virtual influencers outperform human influencers. Technological Forecasting and Social Change, 200, 123113.</a:t>
+            </a:r>
+            <a:endParaRPr lang="en-US" sz="1200" dirty="0"/>
+          </a:p>
           <a:p>
             <a:pPr indent="0" marL="0">
-              <a:buNone/>
-            </a:pPr>
-            <a:r>
-              <a:rPr lang="en-US" sz="1700" b="1" dirty="0">
+              <a:spcAft>
+                <a:spcPts val="600"/>
+              </a:spcAft>
+              <a:buNone/>
+            </a:pPr>
+            <a:r>
+              <a:rPr lang="en-US" sz="1200" dirty="0">
                 <a:solidFill>
                   <a:schemeClr val="tx1"/>
                 </a:solidFill>
               </a:rPr>
-              <a:t>Population</a:t>
-            </a:r>
-            <a:endParaRPr lang="en-US" sz="1700" dirty="0"/>
-          </a:p>
-        </p:txBody>
-      </p:sp>
-      <p:sp>
-        <p:nvSpPr>
-          <p:cNvPr id="12" name="Text 8"/>
-          <p:cNvSpPr txBox="1"/>
-          <p:nvPr/>
-        </p:nvSpPr>
-        <p:spPr>
-          <a:xfrm>
-            <a:off x="4507992" y="2468880"/>
-            <a:ext cx="3200400" cy="1188720"/>
-          </a:xfrm>
-          <a:prstGeom prst="rect">
-            <a:avLst/>
-          </a:prstGeom>
-          <a:noFill/>
-          <a:ln/>
-        </p:spPr>
-        <p:txBody>
-          <a:bodyPr wrap="square" lIns="0" tIns="0" rIns="0" bIns="0" rtlCol="0" anchor="t"/>
-          <a:lstStyle/>
+              <a:t>Belanche, D., Casaló, L. V., &amp; Flavián, M. (2024). Human versus virtual influences, a comparative study. Journal of Business Research, 173, 114493.</a:t>
+            </a:r>
+            <a:endParaRPr lang="en-US" sz="1200" dirty="0"/>
+          </a:p>
           <a:p>
             <a:pPr indent="0" marL="0">
-              <a:buNone/>
-            </a:pPr>
-            <a:r>
-              <a:rPr lang="en-US" sz="1400" dirty="0">
-                <a:solidFill>
-                  <a:schemeClr val="tx2"/>
-                </a:solidFill>
-              </a:rPr>
-              <a:t>Gen Z consumers (born 1997–2012) who follow or have seen virtual influencers</a:t>
-            </a:r>
-            <a:endParaRPr lang="en-US" sz="1400" dirty="0"/>
-          </a:p>
-        </p:txBody>
-      </p:sp>
-      <p:sp>
-        <p:nvSpPr>
-          <p:cNvPr id="13" name="Sampling card"/>
-          <p:cNvSpPr/>
-          <p:nvPr/>
-        </p:nvSpPr>
-        <p:spPr>
-          <a:xfrm>
-            <a:off x="8101584" y="1600200"/>
-            <a:ext cx="3538728" cy="2148840"/>
-          </a:xfrm>
-          <a:prstGeom prst="rect">
-            <a:avLst/>
-          </a:prstGeom>
-          <a:solidFill>
-            <a:schemeClr val="bg2"/>
-          </a:solidFill>
-          <a:ln w="12700">
-            <a:solidFill>
-              <a:schemeClr val="bg2"/>
-            </a:solidFill>
-            <a:prstDash val="solid"/>
-          </a:ln>
-        </p:spPr>
-      </p:sp>
-      <p:sp>
-        <p:nvSpPr>
-          <p:cNvPr id="14" name="Sampling circle"/>
-          <p:cNvSpPr/>
-          <p:nvPr/>
-        </p:nvSpPr>
-        <p:spPr>
-          <a:xfrm>
-            <a:off x="8284464" y="1783080"/>
-            <a:ext cx="548640" cy="548640"/>
-          </a:xfrm>
-          <a:prstGeom prst="ellipse">
-            <a:avLst/>
-          </a:prstGeom>
-          <a:solidFill>
-            <a:schemeClr val="accent4"/>
-          </a:solidFill>
-          <a:ln w="12700">
-            <a:solidFill>
-              <a:schemeClr val="accent4"/>
-            </a:solidFill>
-            <a:prstDash val="solid"/>
-          </a:ln>
-        </p:spPr>
-      </p:sp>
-      <p:pic>
-        <p:nvPicPr>
-          <p:cNvPr id="15" name="Sampling icon" descr="preencoded.png">    </p:cNvPr>
-          <p:cNvPicPr>
-            <a:picLocks noChangeAspect="1"/>
-          </p:cNvPicPr>
-          <p:nvPr/>
-        </p:nvPicPr>
-        <p:blipFill>
-          <a:blip r:embed="rId3"/>
-          <a:stretch>
-            <a:fillRect/>
-          </a:stretch>
-        </p:blipFill>
-        <p:spPr>
-          <a:xfrm>
-            <a:off x="8421624" y="1920240"/>
-            <a:ext cx="274320" cy="274320"/>
-          </a:xfrm>
-          <a:prstGeom prst="rect">
-            <a:avLst/>
-          </a:prstGeom>
-        </p:spPr>
-      </p:pic>
-      <p:sp>
-        <p:nvSpPr>
-          <p:cNvPr id="16" name="Text 11"/>
-          <p:cNvSpPr txBox="1"/>
-          <p:nvPr/>
-        </p:nvSpPr>
-        <p:spPr>
-          <a:xfrm>
-            <a:off x="8970264" y="1783080"/>
-            <a:ext cx="2560320" cy="548640"/>
-          </a:xfrm>
-          <a:prstGeom prst="rect">
-            <a:avLst/>
-          </a:prstGeom>
-          <a:noFill/>
-          <a:ln/>
-        </p:spPr>
-        <p:txBody>
-          <a:bodyPr wrap="square" lIns="0" tIns="0" rIns="0" bIns="0" rtlCol="0" anchor="ctr"/>
-          <a:lstStyle/>
+              <a:spcAft>
+                <a:spcPts val="600"/>
+              </a:spcAft>
+              <a:buNone/>
+            </a:pPr>
+            <a:r>
+              <a:rPr lang="en-US" sz="1200" dirty="0">
+                <a:solidFill>
+                  <a:schemeClr val="tx1"/>
+                </a:solidFill>
+              </a:rPr>
+              <a:t>Byun, K. J., &amp; Ahn, S. J. (2023). A systematic review of virtual influencers. Journal of Interactive Advertising, 23(4), 293–306.</a:t>
+            </a:r>
+            <a:endParaRPr lang="en-US" sz="1200" dirty="0"/>
+          </a:p>
           <a:p>
             <a:pPr indent="0" marL="0">
-              <a:buNone/>
-            </a:pPr>
-            <a:r>
-              <a:rPr lang="en-US" sz="1700" b="1" dirty="0">
+              <a:spcAft>
+                <a:spcPts val="600"/>
+              </a:spcAft>
+              <a:buNone/>
+            </a:pPr>
+            <a:r>
+              <a:rPr lang="en-US" sz="1200" dirty="0">
                 <a:solidFill>
                   <a:schemeClr val="tx1"/>
                 </a:solidFill>
               </a:rPr>
-              <a:t>Sampling</a:t>
-            </a:r>
-            <a:endParaRPr lang="en-US" sz="1700" dirty="0"/>
-          </a:p>
-        </p:txBody>
-      </p:sp>
-      <p:sp>
-        <p:nvSpPr>
-          <p:cNvPr id="17" name="Text 12"/>
-          <p:cNvSpPr txBox="1"/>
-          <p:nvPr/>
-        </p:nvSpPr>
-        <p:spPr>
-          <a:xfrm>
-            <a:off x="8284464" y="2468880"/>
-            <a:ext cx="3200400" cy="1188720"/>
-          </a:xfrm>
-          <a:prstGeom prst="rect">
-            <a:avLst/>
-          </a:prstGeom>
-          <a:noFill/>
-          <a:ln/>
-        </p:spPr>
-        <p:txBody>
-          <a:bodyPr wrap="square" lIns="0" tIns="0" rIns="0" bIns="0" rtlCol="0" anchor="t"/>
-          <a:lstStyle/>
+              <a:t>Cascio Rizzo, G. L., Villarroel Ordenes, F., &amp; Berger, J. (2026). What drives virtual influencers' impact? Journal of the Academy of Marketing Science.</a:t>
+            </a:r>
+            <a:endParaRPr lang="en-US" sz="1200" dirty="0"/>
+          </a:p>
           <a:p>
             <a:pPr indent="0" marL="0">
-              <a:buNone/>
-            </a:pPr>
-            <a:r>
-              <a:rPr lang="en-US" sz="1400" dirty="0">
-                <a:solidFill>
-                  <a:schemeClr val="tx2"/>
-                </a:solidFill>
-              </a:rPr>
-              <a:t>Purposive / convenience sampling; sample size: [n] respondents</a:t>
-            </a:r>
-            <a:endParaRPr lang="en-US" sz="1400" dirty="0"/>
-          </a:p>
-        </p:txBody>
-      </p:sp>
-      <p:sp>
-        <p:nvSpPr>
-          <p:cNvPr id="18" name="Data collection card"/>
-          <p:cNvSpPr/>
-          <p:nvPr/>
-        </p:nvSpPr>
-        <p:spPr>
-          <a:xfrm>
-            <a:off x="548640" y="3977640"/>
-            <a:ext cx="3538728" cy="2148840"/>
-          </a:xfrm>
-          <a:prstGeom prst="rect">
-            <a:avLst/>
-          </a:prstGeom>
-          <a:solidFill>
-            <a:schemeClr val="bg2"/>
-          </a:solidFill>
-          <a:ln w="12700">
-            <a:solidFill>
-              <a:schemeClr val="bg2"/>
-            </a:solidFill>
-            <a:prstDash val="solid"/>
-          </a:ln>
-        </p:spPr>
-      </p:sp>
-      <p:sp>
-        <p:nvSpPr>
-          <p:cNvPr id="19" name="Data collection circle"/>
-          <p:cNvSpPr/>
-          <p:nvPr/>
-        </p:nvSpPr>
-        <p:spPr>
-          <a:xfrm>
-            <a:off x="731520" y="4160520"/>
-            <a:ext cx="548640" cy="548640"/>
-          </a:xfrm>
-          <a:prstGeom prst="ellipse">
-            <a:avLst/>
-          </a:prstGeom>
-          <a:solidFill>
-            <a:schemeClr val="tx2"/>
-          </a:solidFill>
-          <a:ln w="12700">
-            <a:solidFill>
-              <a:schemeClr val="tx2"/>
-            </a:solidFill>
-            <a:prstDash val="solid"/>
-          </a:ln>
-        </p:spPr>
-      </p:sp>
-      <p:pic>
-        <p:nvPicPr>
-          <p:cNvPr id="20" name="Data collection icon" descr="preencoded.png">    </p:cNvPr>
-          <p:cNvPicPr>
-            <a:picLocks noChangeAspect="1"/>
-          </p:cNvPicPr>
-          <p:nvPr/>
-        </p:nvPicPr>
-        <p:blipFill>
-          <a:blip r:embed="rId4"/>
-          <a:stretch>
-            <a:fillRect/>
-          </a:stretch>
-        </p:blipFill>
-        <p:spPr>
-          <a:xfrm>
-            <a:off x="868680" y="4297680"/>
-            <a:ext cx="274320" cy="274320"/>
-          </a:xfrm>
-          <a:prstGeom prst="rect">
-            <a:avLst/>
-          </a:prstGeom>
-        </p:spPr>
-      </p:pic>
-      <p:sp>
-        <p:nvSpPr>
-          <p:cNvPr id="21" name="Text 15"/>
-          <p:cNvSpPr txBox="1"/>
-          <p:nvPr/>
-        </p:nvSpPr>
-        <p:spPr>
-          <a:xfrm>
-            <a:off x="1417320" y="4160520"/>
-            <a:ext cx="2560320" cy="548640"/>
-          </a:xfrm>
-          <a:prstGeom prst="rect">
-            <a:avLst/>
-          </a:prstGeom>
-          <a:noFill/>
-          <a:ln/>
-        </p:spPr>
-        <p:txBody>
-          <a:bodyPr wrap="square" lIns="0" tIns="0" rIns="0" bIns="0" rtlCol="0" anchor="ctr"/>
-          <a:lstStyle/>
+              <a:spcAft>
+                <a:spcPts val="600"/>
+              </a:spcAft>
+              <a:buNone/>
+            </a:pPr>
+            <a:r>
+              <a:rPr lang="en-US" sz="1200" dirty="0">
+                <a:solidFill>
+                  <a:schemeClr val="tx1"/>
+                </a:solidFill>
+              </a:rPr>
+              <a:t>Djafarova, E., &amp; Bowes, T. (2021). 'Instagram made me buy it': Generation Z impulse purchases in fashion industry. Journal of Retailing and Consumer Services, 59, 102345.</a:t>
+            </a:r>
+            <a:endParaRPr lang="en-US" sz="1200" dirty="0"/>
+          </a:p>
           <a:p>
             <a:pPr indent="0" marL="0">
-              <a:buNone/>
-            </a:pPr>
-            <a:r>
-              <a:rPr lang="en-US" sz="1700" b="1" dirty="0">
+              <a:spcAft>
+                <a:spcPts val="600"/>
+              </a:spcAft>
+              <a:buNone/>
+            </a:pPr>
+            <a:r>
+              <a:rPr lang="en-US" sz="1200" dirty="0">
                 <a:solidFill>
                   <a:schemeClr val="tx1"/>
                 </a:solidFill>
               </a:rPr>
-              <a:t>Data collection</a:t>
-            </a:r>
-            <a:endParaRPr lang="en-US" sz="1700" dirty="0"/>
-          </a:p>
-        </p:txBody>
-      </p:sp>
-      <p:sp>
-        <p:nvSpPr>
-          <p:cNvPr id="22" name="Text 16"/>
-          <p:cNvSpPr txBox="1"/>
-          <p:nvPr/>
-        </p:nvSpPr>
-        <p:spPr>
-          <a:xfrm>
-            <a:off x="731520" y="4846320"/>
-            <a:ext cx="3200400" cy="1188720"/>
-          </a:xfrm>
-          <a:prstGeom prst="rect">
-            <a:avLst/>
-          </a:prstGeom>
-          <a:noFill/>
-          <a:ln/>
-        </p:spPr>
-        <p:txBody>
-          <a:bodyPr wrap="square" lIns="0" tIns="0" rIns="0" bIns="0" rtlCol="0" anchor="t"/>
-          <a:lstStyle/>
+              <a:t>Epley, N., Waytz, A., &amp; Cacioppo, J. T. (2007). On seeing human: A three-factor theory of anthropomorphism. Psychological Review, 114(4), 864–886.</a:t>
+            </a:r>
+            <a:endParaRPr lang="en-US" sz="1200" dirty="0"/>
+          </a:p>
           <a:p>
             <a:pPr indent="0" marL="0">
-              <a:buNone/>
-            </a:pPr>
-            <a:r>
-              <a:rPr lang="en-US" sz="1400" dirty="0">
-                <a:solidFill>
-                  <a:schemeClr val="tx2"/>
-                </a:solidFill>
-              </a:rPr>
-              <a:t>Structured online questionnaire on a 5-point Likert scale</a:t>
-            </a:r>
-            <a:endParaRPr lang="en-US" sz="1400" dirty="0"/>
-          </a:p>
-        </p:txBody>
-      </p:sp>
-      <p:sp>
-        <p:nvSpPr>
-          <p:cNvPr id="23" name="Measurement scales card"/>
-          <p:cNvSpPr/>
-          <p:nvPr/>
-        </p:nvSpPr>
-        <p:spPr>
-          <a:xfrm>
-            <a:off x="4325112" y="3977640"/>
-            <a:ext cx="3538728" cy="2148840"/>
-          </a:xfrm>
-          <a:prstGeom prst="rect">
-            <a:avLst/>
-          </a:prstGeom>
-          <a:solidFill>
-            <a:schemeClr val="bg2"/>
-          </a:solidFill>
-          <a:ln w="12700">
-            <a:solidFill>
-              <a:schemeClr val="bg2"/>
-            </a:solidFill>
-            <a:prstDash val="solid"/>
-          </a:ln>
-        </p:spPr>
-      </p:sp>
-      <p:sp>
-        <p:nvSpPr>
-          <p:cNvPr id="24" name="Measurement scales circle"/>
-          <p:cNvSpPr/>
-          <p:nvPr/>
-        </p:nvSpPr>
-        <p:spPr>
-          <a:xfrm>
-            <a:off x="4507992" y="4160520"/>
-            <a:ext cx="548640" cy="548640"/>
-          </a:xfrm>
-          <a:prstGeom prst="ellipse">
-            <a:avLst/>
-          </a:prstGeom>
-          <a:solidFill>
-            <a:schemeClr val="accent1"/>
-          </a:solidFill>
-          <a:ln w="12700">
-            <a:solidFill>
-              <a:schemeClr val="accent1"/>
-            </a:solidFill>
-            <a:prstDash val="solid"/>
-          </a:ln>
-        </p:spPr>
-      </p:sp>
-      <p:pic>
-        <p:nvPicPr>
-          <p:cNvPr id="25" name="Measurement scales icon" descr="preencoded.png">    </p:cNvPr>
-          <p:cNvPicPr>
-            <a:picLocks noChangeAspect="1"/>
-          </p:cNvPicPr>
-          <p:nvPr/>
-        </p:nvPicPr>
-        <p:blipFill>
-          <a:blip r:embed="rId5"/>
-          <a:stretch>
-            <a:fillRect/>
-          </a:stretch>
-        </p:blipFill>
-        <p:spPr>
-          <a:xfrm>
-            <a:off x="4645152" y="4297680"/>
-            <a:ext cx="274320" cy="274320"/>
-          </a:xfrm>
-          <a:prstGeom prst="rect">
-            <a:avLst/>
-          </a:prstGeom>
-        </p:spPr>
-      </p:pic>
-      <p:sp>
-        <p:nvSpPr>
-          <p:cNvPr id="26" name="Text 19"/>
-          <p:cNvSpPr txBox="1"/>
-          <p:nvPr/>
-        </p:nvSpPr>
-        <p:spPr>
-          <a:xfrm>
-            <a:off x="5193792" y="4160520"/>
-            <a:ext cx="2560320" cy="548640"/>
-          </a:xfrm>
-          <a:prstGeom prst="rect">
-            <a:avLst/>
-          </a:prstGeom>
-          <a:noFill/>
-          <a:ln/>
-        </p:spPr>
-        <p:txBody>
-          <a:bodyPr wrap="square" lIns="0" tIns="0" rIns="0" bIns="0" rtlCol="0" anchor="ctr"/>
-          <a:lstStyle/>
+              <a:spcAft>
+                <a:spcPts val="600"/>
+              </a:spcAft>
+              <a:buNone/>
+            </a:pPr>
+            <a:r>
+              <a:rPr lang="en-US" sz="1200" dirty="0">
+                <a:solidFill>
+                  <a:schemeClr val="tx1"/>
+                </a:solidFill>
+              </a:rPr>
+              <a:t>George, J. P., Muttungal, P. V., Priya, N., &amp; Davidson, B. G. J. (2026). Credibility, engagement, and purchase: How virtual influencers drive Gen Zs consumer behavior. Emerald Publishing.</a:t>
+            </a:r>
+            <a:endParaRPr lang="en-US" sz="1200" dirty="0"/>
+          </a:p>
           <a:p>
             <a:pPr indent="0" marL="0">
-              <a:buNone/>
-            </a:pPr>
-            <a:r>
-              <a:rPr lang="en-US" sz="1700" b="1" dirty="0">
+              <a:spcAft>
+                <a:spcPts val="600"/>
+              </a:spcAft>
+              <a:buNone/>
+            </a:pPr>
+            <a:r>
+              <a:rPr lang="en-US" sz="1200" dirty="0">
                 <a:solidFill>
                   <a:schemeClr val="tx1"/>
                 </a:solidFill>
               </a:rPr>
-              <a:t>Measurement scales</a:t>
-            </a:r>
-            <a:endParaRPr lang="en-US" sz="1700" dirty="0"/>
-          </a:p>
-        </p:txBody>
-      </p:sp>
-      <p:sp>
-        <p:nvSpPr>
-          <p:cNvPr id="27" name="Text 20"/>
-          <p:cNvSpPr txBox="1"/>
-          <p:nvPr/>
-        </p:nvSpPr>
-        <p:spPr>
-          <a:xfrm>
-            <a:off x="4507992" y="4846320"/>
-            <a:ext cx="3200400" cy="1188720"/>
-          </a:xfrm>
-          <a:prstGeom prst="rect">
-            <a:avLst/>
-          </a:prstGeom>
-          <a:noFill/>
-          <a:ln/>
-        </p:spPr>
-        <p:txBody>
-          <a:bodyPr wrap="square" lIns="0" tIns="0" rIns="0" bIns="0" rtlCol="0" anchor="t"/>
-          <a:lstStyle/>
+              <a:t>Gerlich, M. (2023). The power of virtual influencers: Impact on consumer behaviour and attitudes in the age of AI. Administrative Sciences, 13(8), 178.</a:t>
+            </a:r>
+            <a:endParaRPr lang="en-US" sz="1200" dirty="0"/>
+          </a:p>
           <a:p>
             <a:pPr indent="0" marL="0">
-              <a:buNone/>
-            </a:pPr>
-            <a:r>
-              <a:rPr lang="en-US" sz="1400" dirty="0">
-                <a:solidFill>
-                  <a:schemeClr val="tx2"/>
-                </a:solidFill>
-              </a:rPr>
-              <a:t>Adapted from Lee &amp; Eastin (2021), Bartneck et al. (2009), McCroskey et al. (1975), Ohanian (1990), Spears &amp; Singh (2004)</a:t>
-            </a:r>
-            <a:endParaRPr lang="en-US" sz="1400" dirty="0"/>
-          </a:p>
-        </p:txBody>
-      </p:sp>
-      <p:sp>
-        <p:nvSpPr>
-          <p:cNvPr id="28" name="Analysis card"/>
-          <p:cNvSpPr/>
-          <p:nvPr/>
-        </p:nvSpPr>
-        <p:spPr>
-          <a:xfrm>
-            <a:off x="8101584" y="3977640"/>
-            <a:ext cx="3538728" cy="2148840"/>
-          </a:xfrm>
-          <a:prstGeom prst="rect">
-            <a:avLst/>
-          </a:prstGeom>
-          <a:solidFill>
-            <a:schemeClr val="bg2"/>
-          </a:solidFill>
-          <a:ln w="12700">
-            <a:solidFill>
-              <a:schemeClr val="bg2"/>
-            </a:solidFill>
-            <a:prstDash val="solid"/>
-          </a:ln>
-        </p:spPr>
-      </p:sp>
-      <p:sp>
-        <p:nvSpPr>
-          <p:cNvPr id="29" name="Analysis circle"/>
-          <p:cNvSpPr/>
-          <p:nvPr/>
-        </p:nvSpPr>
-        <p:spPr>
-          <a:xfrm>
-            <a:off x="8284464" y="4160520"/>
-            <a:ext cx="548640" cy="548640"/>
-          </a:xfrm>
-          <a:prstGeom prst="ellipse">
-            <a:avLst/>
-          </a:prstGeom>
-          <a:solidFill>
-            <a:schemeClr val="accent4"/>
-          </a:solidFill>
-          <a:ln w="12700">
-            <a:solidFill>
-              <a:schemeClr val="accent4"/>
-            </a:solidFill>
-            <a:prstDash val="solid"/>
-          </a:ln>
-        </p:spPr>
-      </p:sp>
-      <p:pic>
-        <p:nvPicPr>
-          <p:cNvPr id="30" name="Analysis icon" descr="preencoded.png">    </p:cNvPr>
-          <p:cNvPicPr>
-            <a:picLocks noChangeAspect="1"/>
-          </p:cNvPicPr>
-          <p:nvPr/>
-        </p:nvPicPr>
-        <p:blipFill>
-          <a:blip r:embed="rId6"/>
-          <a:stretch>
-            <a:fillRect/>
-          </a:stretch>
-        </p:blipFill>
-        <p:spPr>
-          <a:xfrm>
-            <a:off x="8421624" y="4297680"/>
-            <a:ext cx="274320" cy="274320"/>
-          </a:xfrm>
-          <a:prstGeom prst="rect">
-            <a:avLst/>
-          </a:prstGeom>
-        </p:spPr>
-      </p:pic>
-      <p:sp>
-        <p:nvSpPr>
-          <p:cNvPr id="31" name="Text 23"/>
-          <p:cNvSpPr txBox="1"/>
-          <p:nvPr/>
-        </p:nvSpPr>
-        <p:spPr>
-          <a:xfrm>
-            <a:off x="8970264" y="4160520"/>
-            <a:ext cx="2560320" cy="548640"/>
-          </a:xfrm>
-          <a:prstGeom prst="rect">
-            <a:avLst/>
-          </a:prstGeom>
-          <a:noFill/>
-          <a:ln/>
-        </p:spPr>
-        <p:txBody>
-          <a:bodyPr wrap="square" lIns="0" tIns="0" rIns="0" bIns="0" rtlCol="0" anchor="ctr"/>
-          <a:lstStyle/>
+              <a:spcAft>
+                <a:spcPts val="600"/>
+              </a:spcAft>
+              <a:buNone/>
+            </a:pPr>
+            <a:r>
+              <a:rPr lang="en-US" sz="1200" dirty="0">
+                <a:solidFill>
+                  <a:schemeClr val="tx1"/>
+                </a:solidFill>
+              </a:rPr>
+              <a:t>Jha, S., Chaudhary, R., &amp; Shukla, B. (2025). Trust dynamics of virtual influencers: Exploring their influence on fashion purchase decisions. Innovative Marketing, 21(3), 226–236.</a:t>
+            </a:r>
+            <a:endParaRPr lang="en-US" sz="1200" dirty="0"/>
+          </a:p>
           <a:p>
             <a:pPr indent="0" marL="0">
-              <a:buNone/>
-            </a:pPr>
-            <a:r>
-              <a:rPr lang="en-US" sz="1700" b="1" dirty="0">
+              <a:spcAft>
+                <a:spcPts val="600"/>
+              </a:spcAft>
+              <a:buNone/>
+            </a:pPr>
+            <a:r>
+              <a:rPr lang="en-US" sz="1200" dirty="0">
                 <a:solidFill>
                   <a:schemeClr val="tx1"/>
                 </a:solidFill>
               </a:rPr>
-              <a:t>Analysis</a:t>
-            </a:r>
-            <a:endParaRPr lang="en-US" sz="1700" dirty="0"/>
-          </a:p>
-        </p:txBody>
-      </p:sp>
-      <p:sp>
-        <p:nvSpPr>
-          <p:cNvPr id="32" name="Text 24"/>
-          <p:cNvSpPr txBox="1"/>
-          <p:nvPr/>
-        </p:nvSpPr>
-        <p:spPr>
-          <a:xfrm>
-            <a:off x="8284464" y="4846320"/>
-            <a:ext cx="3200400" cy="1188720"/>
-          </a:xfrm>
-          <a:prstGeom prst="rect">
-            <a:avLst/>
-          </a:prstGeom>
-          <a:noFill/>
-          <a:ln/>
-        </p:spPr>
-        <p:txBody>
-          <a:bodyPr wrap="square" lIns="0" tIns="0" rIns="0" bIns="0" rtlCol="0" anchor="t"/>
-          <a:lstStyle/>
-          <a:p>
-            <a:pPr indent="0" marL="0">
-              <a:buNone/>
-            </a:pPr>
-            <a:r>
-              <a:rPr lang="en-US" sz="1400" dirty="0">
-                <a:solidFill>
-                  <a:schemeClr val="tx2"/>
-                </a:solidFill>
-              </a:rPr>
-              <a:t>Reliability &amp; validity tests, PLS-SEM / regression, mediation analysis (bootstrapping)</a:t>
-            </a:r>
-            <a:endParaRPr lang="en-US" sz="1400" dirty="0"/>
+              <a:t>Lee, J. A., &amp; Eastin, M. S. (2021). Perceived authenticity of social media influencers: Scale development and validation. Journal of Research in Interactive Marketing, 15(4), 822–841.</a:t>
+            </a:r>
+            <a:endParaRPr lang="en-US" sz="1200" dirty="0"/>
           </a:p>
         </p:txBody>
       </p:sp>
@@ -8091,7 +7317,7 @@
                   <a:schemeClr val="tx1"/>
                 </a:solidFill>
               </a:rPr>
-              <a:t>REFERENCES (SELECTED)</a:t>
+              <a:t>REFERENCES (CONTD.)</a:t>
             </a:r>
             <a:endParaRPr lang="en-US" sz="2600" dirty="0"/>
           </a:p>
@@ -8130,7 +7356,7 @@
                   <a:schemeClr val="tx1"/>
                 </a:solidFill>
               </a:rPr>
-              <a:t>Allal-Chérif, O., Puertas, R., &amp; Carracedo, P. (2024). Intelligent influencer marketing: How AI-powered virtual influencers outperform human influencers. Technological Forecasting and Social Change, 200, 123113.</a:t>
+              <a:t>Lonsdale, N., Aydin, G., &amp; Magtibay, R. (2025). Anthropomorphism and diversity in virtual humans: Their influence on the trust and attitudes of Gen Z consumers. Corporate Communications, 30(5), 888–914.</a:t>
             </a:r>
             <a:endParaRPr lang="en-US" sz="1200" dirty="0"/>
           </a:p>
@@ -8147,7 +7373,7 @@
                   <a:schemeClr val="tx1"/>
                 </a:solidFill>
               </a:rPr>
-              <a:t>Belanche, D., Casaló, L. V., &amp; Flavián, M. (2024). Human versus virtual influences, a comparative study. Journal of Business Research, 173, 114493.</a:t>
+              <a:t>Lou, C., Kiew, S. T. J., Chen, T., Lee, T. Y. M., Ong, J. E. C., &amp; Phua, Z. (2023). Authentically fake? How consumers respond to the influence of virtual influencers. Journal of Advertising, 52(4), 540–557.</a:t>
             </a:r>
             <a:endParaRPr lang="en-US" sz="1200" dirty="0"/>
           </a:p>
@@ -8164,7 +7390,7 @@
                   <a:schemeClr val="tx1"/>
                 </a:solidFill>
               </a:rPr>
-              <a:t>Byun, K. J., &amp; Ahn, S. J. (2023). A systematic review of virtual influencers. Journal of Interactive Advertising, 23(4), 293–306.</a:t>
+              <a:t>Lou, C., &amp; Yuan, S. (2019). Influencer marketing: How message value and credibility affect consumer trust of branded content on social media. Journal of Interactive Advertising, 19(1), 58–73.</a:t>
             </a:r>
             <a:endParaRPr lang="en-US" sz="1200" dirty="0"/>
           </a:p>
@@ -8181,7 +7407,7 @@
                   <a:schemeClr val="tx1"/>
                 </a:solidFill>
               </a:rPr>
-              <a:t>Cascio Rizzo, G. L., Villarroel Ordenes, F., &amp; Berger, J. (2026). What drives virtual influencers' impact? Journal of the Academy of Marketing Science.</a:t>
+              <a:t>Mayer, R. C., Davis, J. H., &amp; Schoorman, F. D. (1995). An integrative model of organizational trust. Academy of Management Review, 20(3), 709–734.</a:t>
             </a:r>
             <a:endParaRPr lang="en-US" sz="1200" dirty="0"/>
           </a:p>
@@ -8198,7 +7424,7 @@
                   <a:schemeClr val="tx1"/>
                 </a:solidFill>
               </a:rPr>
-              <a:t>Djafarova, E., &amp; Bowes, T. (2021). 'Instagram made me buy it': Generation Z impulse purchases in fashion industry. Journal of Retailing and Consumer Services, 59, 102345.</a:t>
+              <a:t>McCroskey, J. C., Richmond, V. P., &amp; Daly, J. A. (1975). The development of a measure of perceived homophily in interpersonal communication. Human Communication Research, 1(4), 323–332.</a:t>
             </a:r>
             <a:endParaRPr lang="en-US" sz="1200" dirty="0"/>
           </a:p>
@@ -8215,7 +7441,7 @@
                   <a:schemeClr val="tx1"/>
                 </a:solidFill>
               </a:rPr>
-              <a:t>Epley, N., Waytz, A., &amp; Cacioppo, J. T. (2007). On seeing human: A three-factor theory of anthropomorphism. Psychological Review, 114(4), 864–886.</a:t>
+              <a:t>Mehrabian, A., &amp; Russell, J. A. (1974). An approach to environmental psychology. MIT Press.</a:t>
             </a:r>
             <a:endParaRPr lang="en-US" sz="1200" dirty="0"/>
           </a:p>
@@ -8232,7 +7458,7 @@
                   <a:schemeClr val="tx1"/>
                 </a:solidFill>
               </a:rPr>
-              <a:t>George, J. P., Muttungal, P. V., Priya, N., &amp; Davidson, B. G. J. (2026). Credibility, engagement, and purchase: How virtual influencers drive Gen Zs consumer behavior. Emerald Publishing.</a:t>
+              <a:t>Ohanian, R. (1990). Construction and validation of a scale to measure celebrity endorsers' perceived expertise, trustworthiness, and attractiveness. Journal of Advertising, 19(3), 39–52.</a:t>
             </a:r>
             <a:endParaRPr lang="en-US" sz="1200" dirty="0"/>
           </a:p>
@@ -8249,7 +7475,7 @@
                   <a:schemeClr val="tx1"/>
                 </a:solidFill>
               </a:rPr>
-              <a:t>Gerlich, M. (2023). The power of virtual influencers: Impact on consumer behaviour and attitudes in the age of AI. Administrative Sciences, 13(8), 178.</a:t>
+              <a:t>Sands, S., Campbell, C. L., Plangger, K., &amp; Ferraro, C. (2022). Unreal influence: Leveraging AI in influencer marketing. European Journal of Marketing, 56(6), 1721–1747.</a:t>
             </a:r>
             <a:endParaRPr lang="en-US" sz="1200" dirty="0"/>
           </a:p>
@@ -8266,7 +7492,7 @@
                   <a:schemeClr val="tx1"/>
                 </a:solidFill>
               </a:rPr>
-              <a:t>Jha, S., Chaudhary, R., &amp; Shukla, B. (2025). Trust dynamics of virtual influencers: Exploring their influence on fashion purchase decisions. Innovative Marketing, 21(3), 226–236.</a:t>
+              <a:t>Spears, N., &amp; Singh, S. N. (2004). Measuring attitude toward the brand and purchase intentions. Journal of Current Issues &amp; Research in Advertising, 26(2), 53–66.</a:t>
             </a:r>
             <a:endParaRPr lang="en-US" sz="1200" dirty="0"/>
           </a:p>
@@ -8283,7 +7509,7 @@
                   <a:schemeClr val="tx1"/>
                 </a:solidFill>
               </a:rPr>
-              <a:t>Lee, J. A., &amp; Eastin, M. S. (2021). Perceived authenticity of social media influencers: Scale development and validation. Journal of Research in Interactive Marketing, 15(4), 822–841.</a:t>
+              <a:t>Stein, J.-P., Breves, P. L., &amp; Anders, N. (2024). Parasocial interactions with real and virtual influencers: The role of perceived similarity and human-likeness. New Media &amp; Society, 26(6), 3433–3453.</a:t>
             </a:r>
             <a:endParaRPr lang="en-US" sz="1200" dirty="0"/>
           </a:p>
@@ -8345,306 +7571,6 @@
 <file path=ppt/slides/slide17.xml><?xml version="1.0" encoding="utf-8"?>
 <p:sld xmlns:a="http://schemas.openxmlformats.org/drawingml/2006/main" xmlns:r="http://schemas.openxmlformats.org/officeDocument/2006/relationships" xmlns:p="http://schemas.openxmlformats.org/presentationml/2006/main">
   <p:cSld name="Slide 17">
-    <p:spTree>
-      <p:nvGrpSpPr>
-        <p:cNvPr id="1" name=""/>
-        <p:cNvGrpSpPr/>
-        <p:nvPr/>
-      </p:nvGrpSpPr>
-      <p:grpSpPr>
-        <a:xfrm>
-          <a:off x="0" y="0"/>
-          <a:ext cx="0" cy="0"/>
-          <a:chOff x="0" y="0"/>
-          <a:chExt cx="0" cy="0"/>
-        </a:xfrm>
-      </p:grpSpPr>
-      <p:sp>
-        <p:nvSpPr>
-          <p:cNvPr id="2" name="Text 3"/>
-          <p:cNvSpPr/>
-          <p:nvPr>
-            <p:ph idx="103" type="title" hasCustomPrompt="1"/>
-          </p:nvPr>
-        </p:nvSpPr>
-        <p:spPr>
-          <a:xfrm>
-            <a:off x="548640" y="749808"/>
-            <a:ext cx="11091672" cy="658368"/>
-          </a:xfrm>
-          <a:prstGeom prst="rect">
-            <a:avLst/>
-          </a:prstGeom>
-          <a:noFill/>
-          <a:ln/>
-        </p:spPr>
-        <p:txBody>
-          <a:bodyPr wrap="square" lIns="0" tIns="0" rIns="0" bIns="0" rtlCol="0" anchor="ctr"/>
-          <a:lstStyle/>
-          <a:p>
-            <a:pPr algn="l" indent="0" marL="0">
-              <a:buNone/>
-            </a:pPr>
-            <a:r>
-              <a:rPr lang="en-US" sz="2600" b="1" dirty="0">
-                <a:solidFill>
-                  <a:schemeClr val="tx1"/>
-                </a:solidFill>
-              </a:rPr>
-              <a:t>REFERENCES (CONTD.)</a:t>
-            </a:r>
-            <a:endParaRPr lang="en-US" sz="2600" dirty="0"/>
-          </a:p>
-        </p:txBody>
-      </p:sp>
-      <p:sp>
-        <p:nvSpPr>
-          <p:cNvPr id="3" name="Text 1"/>
-          <p:cNvSpPr txBox="1"/>
-          <p:nvPr/>
-        </p:nvSpPr>
-        <p:spPr>
-          <a:xfrm>
-            <a:off x="548640" y="1554480"/>
-            <a:ext cx="11091672" cy="4846320"/>
-          </a:xfrm>
-          <a:prstGeom prst="rect">
-            <a:avLst/>
-          </a:prstGeom>
-          <a:noFill/>
-          <a:ln/>
-        </p:spPr>
-        <p:txBody>
-          <a:bodyPr wrap="square" lIns="0" tIns="0" rIns="0" bIns="0" rtlCol="0" anchor="t"/>
-          <a:lstStyle/>
-          <a:p>
-            <a:pPr indent="0" marL="0">
-              <a:spcAft>
-                <a:spcPts val="600"/>
-              </a:spcAft>
-              <a:buNone/>
-            </a:pPr>
-            <a:r>
-              <a:rPr lang="en-US" sz="1200" dirty="0">
-                <a:solidFill>
-                  <a:schemeClr val="tx1"/>
-                </a:solidFill>
-              </a:rPr>
-              <a:t>Lonsdale, N., Aydin, G., &amp; Magtibay, R. (2025). Anthropomorphism and diversity in virtual humans: Their influence on the trust and attitudes of Gen Z consumers. Corporate Communications, 30(5), 888–914.</a:t>
-            </a:r>
-            <a:endParaRPr lang="en-US" sz="1200" dirty="0"/>
-          </a:p>
-          <a:p>
-            <a:pPr indent="0" marL="0">
-              <a:spcAft>
-                <a:spcPts val="600"/>
-              </a:spcAft>
-              <a:buNone/>
-            </a:pPr>
-            <a:r>
-              <a:rPr lang="en-US" sz="1200" dirty="0">
-                <a:solidFill>
-                  <a:schemeClr val="tx1"/>
-                </a:solidFill>
-              </a:rPr>
-              <a:t>Lou, C., Kiew, S. T. J., Chen, T., Lee, T. Y. M., Ong, J. E. C., &amp; Phua, Z. (2023). Authentically fake? How consumers respond to the influence of virtual influencers. Journal of Advertising, 52(4), 540–557.</a:t>
-            </a:r>
-            <a:endParaRPr lang="en-US" sz="1200" dirty="0"/>
-          </a:p>
-          <a:p>
-            <a:pPr indent="0" marL="0">
-              <a:spcAft>
-                <a:spcPts val="600"/>
-              </a:spcAft>
-              <a:buNone/>
-            </a:pPr>
-            <a:r>
-              <a:rPr lang="en-US" sz="1200" dirty="0">
-                <a:solidFill>
-                  <a:schemeClr val="tx1"/>
-                </a:solidFill>
-              </a:rPr>
-              <a:t>Lou, C., &amp; Yuan, S. (2019). Influencer marketing: How message value and credibility affect consumer trust of branded content on social media. Journal of Interactive Advertising, 19(1), 58–73.</a:t>
-            </a:r>
-            <a:endParaRPr lang="en-US" sz="1200" dirty="0"/>
-          </a:p>
-          <a:p>
-            <a:pPr indent="0" marL="0">
-              <a:spcAft>
-                <a:spcPts val="600"/>
-              </a:spcAft>
-              <a:buNone/>
-            </a:pPr>
-            <a:r>
-              <a:rPr lang="en-US" sz="1200" dirty="0">
-                <a:solidFill>
-                  <a:schemeClr val="tx1"/>
-                </a:solidFill>
-              </a:rPr>
-              <a:t>Mayer, R. C., Davis, J. H., &amp; Schoorman, F. D. (1995). An integrative model of organizational trust. Academy of Management Review, 20(3), 709–734.</a:t>
-            </a:r>
-            <a:endParaRPr lang="en-US" sz="1200" dirty="0"/>
-          </a:p>
-          <a:p>
-            <a:pPr indent="0" marL="0">
-              <a:spcAft>
-                <a:spcPts val="600"/>
-              </a:spcAft>
-              <a:buNone/>
-            </a:pPr>
-            <a:r>
-              <a:rPr lang="en-US" sz="1200" dirty="0">
-                <a:solidFill>
-                  <a:schemeClr val="tx1"/>
-                </a:solidFill>
-              </a:rPr>
-              <a:t>McCroskey, J. C., Richmond, V. P., &amp; Daly, J. A. (1975). The development of a measure of perceived homophily in interpersonal communication. Human Communication Research, 1(4), 323–332.</a:t>
-            </a:r>
-            <a:endParaRPr lang="en-US" sz="1200" dirty="0"/>
-          </a:p>
-          <a:p>
-            <a:pPr indent="0" marL="0">
-              <a:spcAft>
-                <a:spcPts val="600"/>
-              </a:spcAft>
-              <a:buNone/>
-            </a:pPr>
-            <a:r>
-              <a:rPr lang="en-US" sz="1200" dirty="0">
-                <a:solidFill>
-                  <a:schemeClr val="tx1"/>
-                </a:solidFill>
-              </a:rPr>
-              <a:t>Mehrabian, A., &amp; Russell, J. A. (1974). An approach to environmental psychology. MIT Press.</a:t>
-            </a:r>
-            <a:endParaRPr lang="en-US" sz="1200" dirty="0"/>
-          </a:p>
-          <a:p>
-            <a:pPr indent="0" marL="0">
-              <a:spcAft>
-                <a:spcPts val="600"/>
-              </a:spcAft>
-              <a:buNone/>
-            </a:pPr>
-            <a:r>
-              <a:rPr lang="en-US" sz="1200" dirty="0">
-                <a:solidFill>
-                  <a:schemeClr val="tx1"/>
-                </a:solidFill>
-              </a:rPr>
-              <a:t>Ohanian, R. (1990). Construction and validation of a scale to measure celebrity endorsers' perceived expertise, trustworthiness, and attractiveness. Journal of Advertising, 19(3), 39–52.</a:t>
-            </a:r>
-            <a:endParaRPr lang="en-US" sz="1200" dirty="0"/>
-          </a:p>
-          <a:p>
-            <a:pPr indent="0" marL="0">
-              <a:spcAft>
-                <a:spcPts val="600"/>
-              </a:spcAft>
-              <a:buNone/>
-            </a:pPr>
-            <a:r>
-              <a:rPr lang="en-US" sz="1200" dirty="0">
-                <a:solidFill>
-                  <a:schemeClr val="tx1"/>
-                </a:solidFill>
-              </a:rPr>
-              <a:t>Sands, S., Campbell, C. L., Plangger, K., &amp; Ferraro, C. (2022). Unreal influence: Leveraging AI in influencer marketing. European Journal of Marketing, 56(6), 1721–1747.</a:t>
-            </a:r>
-            <a:endParaRPr lang="en-US" sz="1200" dirty="0"/>
-          </a:p>
-          <a:p>
-            <a:pPr indent="0" marL="0">
-              <a:spcAft>
-                <a:spcPts val="600"/>
-              </a:spcAft>
-              <a:buNone/>
-            </a:pPr>
-            <a:r>
-              <a:rPr lang="en-US" sz="1200" dirty="0">
-                <a:solidFill>
-                  <a:schemeClr val="tx1"/>
-                </a:solidFill>
-              </a:rPr>
-              <a:t>Spears, N., &amp; Singh, S. N. (2004). Measuring attitude toward the brand and purchase intentions. Journal of Current Issues &amp; Research in Advertising, 26(2), 53–66.</a:t>
-            </a:r>
-            <a:endParaRPr lang="en-US" sz="1200" dirty="0"/>
-          </a:p>
-          <a:p>
-            <a:pPr indent="0" marL="0">
-              <a:spcAft>
-                <a:spcPts val="600"/>
-              </a:spcAft>
-              <a:buNone/>
-            </a:pPr>
-            <a:r>
-              <a:rPr lang="en-US" sz="1200" dirty="0">
-                <a:solidFill>
-                  <a:schemeClr val="tx1"/>
-                </a:solidFill>
-              </a:rPr>
-              <a:t>Stein, J.-P., Breves, P. L., &amp; Anders, N. (2024). Parasocial interactions with real and virtual influencers: The role of perceived similarity and human-likeness. New Media &amp; Society, 26(6), 3433–3453.</a:t>
-            </a:r>
-            <a:endParaRPr lang="en-US" sz="1200" dirty="0"/>
-          </a:p>
-        </p:txBody>
-      </p:sp>
-      <p:sp>
-        <p:nvSpPr>
-          <p:cNvPr id="25" name="Slide Number Placeholder 0"/>
-          <p:cNvSpPr>
-            <a:spLocks noGrp="1"/>
-          </p:cNvSpPr>
-          <p:nvPr>
-            <p:ph type="sldNum" sz="quarter" idx="4294967295"/>
-          </p:nvPr>
-        </p:nvSpPr>
-        <p:spPr>
-          <a:xfrm>
-            <a:off x="11247120" y="6400800"/>
-            <a:ext cx="457200" cy="274320"/>
-          </a:xfrm>
-          <a:prstGeom prst="rect">
-            <a:avLst/>
-          </a:prstGeom>
-          <a:extLst>
-            <a:ext uri="{C572A759-6A51-4108-AA02-DFA0A04FC94B}">
-              <ma14:wrappingTextBoxFlag xmlns:ma14="http://schemas.microsoft.com/office/mac/drawingml/2011/main" val="0"/>
-            </a:ext>
-          </a:extLst>
-        </p:spPr>
-        <p:txBody>
-          <a:bodyPr/>
-          <a:lstStyle>
-            <a:lvl1pPr>
-              <a:defRPr sz="1000">
-                <a:solidFill>
-                  <a:schemeClr val="accent3"/>
-                </a:solidFill>
-              </a:defRPr>
-            </a:lvl1pPr>
-          </a:lstStyle>
-          <a:p>
-            <a:pPr algn="r"/>
-            <a:fld id="{F7021451-1387-4CA6-816F-3879F97B5CBC}" type="slidenum">
-              <a:rPr b="0" lang="en-US"/>
-              <a:t>17</a:t>
-            </a:fld>
-            <a:endParaRPr lang="en-US"/>
-          </a:p>
-        </p:txBody>
-      </p:sp>
-    </p:spTree>
-  </p:cSld>
-  <p:clrMapOvr>
-    <a:masterClrMapping/>
-  </p:clrMapOvr>
-</p:sld>
-</file>
-
-<file path=ppt/slides/slide18.xml><?xml version="1.0" encoding="utf-8"?>
-<p:sld xmlns:a="http://schemas.openxmlformats.org/drawingml/2006/main" xmlns:r="http://schemas.openxmlformats.org/officeDocument/2006/relationships" xmlns:p="http://schemas.openxmlformats.org/presentationml/2006/main">
-  <p:cSld name="Slide 18">
     <p:spTree>
       <p:nvGrpSpPr>
         <p:cNvPr id="1" name=""/>

</xml_diff>

<commit_message>
Show full numbered reference list (67 sources)
Co-Authored-By: Claude Opus 5.5 <noreply@anthropic.com>
Claude-Session: https://claude.ai/code/session_01UWkkDpo8nEEYXAoEYMWQqa
</commit_message>
<xml_diff>
--- a/presentation/Virtual_Influencers_Trust_Purchase_Intention_GenZ.pptx
+++ b/presentation/Virtual_Influencers_Trust_Purchase_Intention_GenZ.pptx
@@ -27,9 +27,12 @@
     <p:sldId id="275" r:id="rId21"/>
     <p:sldId id="276" r:id="rId22"/>
     <p:sldId id="277" r:id="rId23"/>
+    <p:sldId id="278" r:id="rId24"/>
+    <p:sldId id="279" r:id="rId25"/>
+    <p:sldId id="280" r:id="rId26"/>
   </p:sldIdLst>
   <p:notesMasterIdLst>
-    <p:notesMasterId r:id="rId24"/>
+    <p:notesMasterId r:id="rId27"/>
   </p:notesMasterIdLst>
   <p:sldSz cx="12192000" cy="6858000"/>
   <p:notesSz cx="6858000" cy="12192000"/>
@@ -128,14 +131,14 @@
   <p:extLst>
     <p:ext uri="{521415D9-36F7-43E2-AB2F-B90AF26B5E84}">
       <p14:sectionLst xmlns:p14="http://schemas.microsoft.com/office/powerpoint/2010/main">
-        <p14:section name="Introduction" id="{db156724-616b-363f-a2c6-7180326e75eb}">
+        <p14:section name="Introduction" id="{f706d599-7bc2-92ce-dcdf-363f084e84a7}">
           <p14:sldIdLst>
             <p14:sldId id="256"/>
             <p14:sldId id="257"/>
             <p14:sldId id="258"/>
           </p14:sldIdLst>
         </p14:section>
-        <p14:section name="Literature Review" id="{8209c875-974a-12e1-cdea-8cd227a62a27}">
+        <p14:section name="Literature Review" id="{5b86c646-cc77-6497-1725-e6d00f0d41da}">
           <p14:sldIdLst>
             <p14:sldId id="259"/>
             <p14:sldId id="260"/>
@@ -150,7 +153,7 @@
             <p14:sldId id="269"/>
           </p14:sldIdLst>
         </p14:section>
-        <p14:section name="Research Design" id="{58eb5e57-7ce3-0aaf-aab2-1f49aa042c95}">
+        <p14:section name="Research Design" id="{36c1bfa3-08f2-0f1d-2ef4-555a1c788604}">
           <p14:sldIdLst>
             <p14:sldId id="270"/>
             <p14:sldId id="271"/>
@@ -158,12 +161,15 @@
             <p14:sldId id="273"/>
           </p14:sldIdLst>
         </p14:section>
-        <p14:section name="References" id="{6afa3c90-69de-cf37-14bf-2ca3b87f08ad}">
+        <p14:section name="References" id="{930d63d5-5078-61a9-f7fc-2731efca7363}">
           <p14:sldIdLst>
             <p14:sldId id="274"/>
             <p14:sldId id="275"/>
             <p14:sldId id="276"/>
             <p14:sldId id="277"/>
+            <p14:sldId id="278"/>
+            <p14:sldId id="279"/>
+            <p14:sldId id="280"/>
           </p14:sldIdLst>
         </p14:section>
       </p14:sectionLst>
@@ -1826,6 +1832,270 @@
             <a:fld id="{F7021451-1387-4CA6-816F-3879F97B5CBC}" type="slidenum">
               <a:rPr lang="en-US"/>
               <a:t>22</a:t>
+            </a:fld>
+            <a:endParaRPr lang="en-US"/>
+          </a:p>
+        </p:txBody>
+      </p:sp>
+    </p:spTree>
+    <p:extLst>
+      <p:ext uri="{BB962C8B-B14F-4D97-AF65-F5344CB8AC3E}">
+        <p14:creationId xmlns:p14="http://schemas.microsoft.com/office/powerpoint/2010/main" val="1024086991"/>
+      </p:ext>
+    </p:extLst>
+  </p:cSld>
+  <p:clrMapOvr>
+    <a:masterClrMapping/>
+  </p:clrMapOvr>
+</p:notes>
+</file>
+
+<file path=ppt/notesSlides/notesSlide23.xml><?xml version="1.0" encoding="utf-8"?>
+<p:notes xmlns:a="http://schemas.openxmlformats.org/drawingml/2006/main" xmlns:r="http://schemas.openxmlformats.org/officeDocument/2006/relationships" xmlns:p="http://schemas.openxmlformats.org/presentationml/2006/main">
+  <p:cSld>
+    <p:spTree>
+      <p:nvGrpSpPr>
+        <p:cNvPr id="1" name=""/>
+        <p:cNvGrpSpPr/>
+        <p:nvPr/>
+      </p:nvGrpSpPr>
+      <p:grpSpPr>
+        <a:xfrm>
+          <a:off x="0" y="0"/>
+          <a:ext cx="0" cy="0"/>
+          <a:chOff x="0" y="0"/>
+          <a:chExt cx="0" cy="0"/>
+        </a:xfrm>
+      </p:grpSpPr>
+      <p:sp>
+        <p:nvSpPr>
+          <p:cNvPr id="2" name="Slide Image Placeholder 1"/>
+          <p:cNvSpPr>
+            <a:spLocks noGrp="1" noRot="1" noChangeAspect="1"/>
+          </p:cNvSpPr>
+          <p:nvPr>
+            <p:ph type="sldImg"/>
+          </p:nvPr>
+        </p:nvSpPr>
+        <p:spPr/>
+      </p:sp>
+      <p:sp>
+        <p:nvSpPr>
+          <p:cNvPr id="3" name="Notes Placeholder 2"/>
+          <p:cNvSpPr>
+            <a:spLocks noGrp="1"/>
+          </p:cNvSpPr>
+          <p:nvPr>
+            <p:ph type="body" idx="1"/>
+          </p:nvPr>
+        </p:nvSpPr>
+        <p:spPr/>
+        <p:txBody>
+          <a:bodyPr/>
+          <a:lstStyle/>
+          <a:p>
+            <a:r>
+              <a:rPr lang="en-US" dirty="0"/>
+              <a:t/>
+            </a:r>
+            <a:endParaRPr lang="en-US" dirty="0"/>
+          </a:p>
+        </p:txBody>
+      </p:sp>
+      <p:sp>
+        <p:nvSpPr>
+          <p:cNvPr id="4" name="Slide Number Placeholder 3"/>
+          <p:cNvSpPr>
+            <a:spLocks noGrp="1"/>
+          </p:cNvSpPr>
+          <p:nvPr>
+            <p:ph type="sldNum" sz="quarter" idx="10"/>
+          </p:nvPr>
+        </p:nvSpPr>
+        <p:spPr/>
+        <p:txBody>
+          <a:bodyPr/>
+          <a:lstStyle/>
+          <a:p>
+            <a:fld id="{F7021451-1387-4CA6-816F-3879F97B5CBC}" type="slidenum">
+              <a:rPr lang="en-US"/>
+              <a:t>23</a:t>
+            </a:fld>
+            <a:endParaRPr lang="en-US"/>
+          </a:p>
+        </p:txBody>
+      </p:sp>
+    </p:spTree>
+    <p:extLst>
+      <p:ext uri="{BB962C8B-B14F-4D97-AF65-F5344CB8AC3E}">
+        <p14:creationId xmlns:p14="http://schemas.microsoft.com/office/powerpoint/2010/main" val="1024086991"/>
+      </p:ext>
+    </p:extLst>
+  </p:cSld>
+  <p:clrMapOvr>
+    <a:masterClrMapping/>
+  </p:clrMapOvr>
+</p:notes>
+</file>
+
+<file path=ppt/notesSlides/notesSlide24.xml><?xml version="1.0" encoding="utf-8"?>
+<p:notes xmlns:a="http://schemas.openxmlformats.org/drawingml/2006/main" xmlns:r="http://schemas.openxmlformats.org/officeDocument/2006/relationships" xmlns:p="http://schemas.openxmlformats.org/presentationml/2006/main">
+  <p:cSld>
+    <p:spTree>
+      <p:nvGrpSpPr>
+        <p:cNvPr id="1" name=""/>
+        <p:cNvGrpSpPr/>
+        <p:nvPr/>
+      </p:nvGrpSpPr>
+      <p:grpSpPr>
+        <a:xfrm>
+          <a:off x="0" y="0"/>
+          <a:ext cx="0" cy="0"/>
+          <a:chOff x="0" y="0"/>
+          <a:chExt cx="0" cy="0"/>
+        </a:xfrm>
+      </p:grpSpPr>
+      <p:sp>
+        <p:nvSpPr>
+          <p:cNvPr id="2" name="Slide Image Placeholder 1"/>
+          <p:cNvSpPr>
+            <a:spLocks noGrp="1" noRot="1" noChangeAspect="1"/>
+          </p:cNvSpPr>
+          <p:nvPr>
+            <p:ph type="sldImg"/>
+          </p:nvPr>
+        </p:nvSpPr>
+        <p:spPr/>
+      </p:sp>
+      <p:sp>
+        <p:nvSpPr>
+          <p:cNvPr id="3" name="Notes Placeholder 2"/>
+          <p:cNvSpPr>
+            <a:spLocks noGrp="1"/>
+          </p:cNvSpPr>
+          <p:nvPr>
+            <p:ph type="body" idx="1"/>
+          </p:nvPr>
+        </p:nvSpPr>
+        <p:spPr/>
+        <p:txBody>
+          <a:bodyPr/>
+          <a:lstStyle/>
+          <a:p>
+            <a:r>
+              <a:rPr lang="en-US" dirty="0"/>
+              <a:t/>
+            </a:r>
+            <a:endParaRPr lang="en-US" dirty="0"/>
+          </a:p>
+        </p:txBody>
+      </p:sp>
+      <p:sp>
+        <p:nvSpPr>
+          <p:cNvPr id="4" name="Slide Number Placeholder 3"/>
+          <p:cNvSpPr>
+            <a:spLocks noGrp="1"/>
+          </p:cNvSpPr>
+          <p:nvPr>
+            <p:ph type="sldNum" sz="quarter" idx="10"/>
+          </p:nvPr>
+        </p:nvSpPr>
+        <p:spPr/>
+        <p:txBody>
+          <a:bodyPr/>
+          <a:lstStyle/>
+          <a:p>
+            <a:fld id="{F7021451-1387-4CA6-816F-3879F97B5CBC}" type="slidenum">
+              <a:rPr lang="en-US"/>
+              <a:t>24</a:t>
+            </a:fld>
+            <a:endParaRPr lang="en-US"/>
+          </a:p>
+        </p:txBody>
+      </p:sp>
+    </p:spTree>
+    <p:extLst>
+      <p:ext uri="{BB962C8B-B14F-4D97-AF65-F5344CB8AC3E}">
+        <p14:creationId xmlns:p14="http://schemas.microsoft.com/office/powerpoint/2010/main" val="1024086991"/>
+      </p:ext>
+    </p:extLst>
+  </p:cSld>
+  <p:clrMapOvr>
+    <a:masterClrMapping/>
+  </p:clrMapOvr>
+</p:notes>
+</file>
+
+<file path=ppt/notesSlides/notesSlide25.xml><?xml version="1.0" encoding="utf-8"?>
+<p:notes xmlns:a="http://schemas.openxmlformats.org/drawingml/2006/main" xmlns:r="http://schemas.openxmlformats.org/officeDocument/2006/relationships" xmlns:p="http://schemas.openxmlformats.org/presentationml/2006/main">
+  <p:cSld>
+    <p:spTree>
+      <p:nvGrpSpPr>
+        <p:cNvPr id="1" name=""/>
+        <p:cNvGrpSpPr/>
+        <p:nvPr/>
+      </p:nvGrpSpPr>
+      <p:grpSpPr>
+        <a:xfrm>
+          <a:off x="0" y="0"/>
+          <a:ext cx="0" cy="0"/>
+          <a:chOff x="0" y="0"/>
+          <a:chExt cx="0" cy="0"/>
+        </a:xfrm>
+      </p:grpSpPr>
+      <p:sp>
+        <p:nvSpPr>
+          <p:cNvPr id="2" name="Slide Image Placeholder 1"/>
+          <p:cNvSpPr>
+            <a:spLocks noGrp="1" noRot="1" noChangeAspect="1"/>
+          </p:cNvSpPr>
+          <p:nvPr>
+            <p:ph type="sldImg"/>
+          </p:nvPr>
+        </p:nvSpPr>
+        <p:spPr/>
+      </p:sp>
+      <p:sp>
+        <p:nvSpPr>
+          <p:cNvPr id="3" name="Notes Placeholder 2"/>
+          <p:cNvSpPr>
+            <a:spLocks noGrp="1"/>
+          </p:cNvSpPr>
+          <p:nvPr>
+            <p:ph type="body" idx="1"/>
+          </p:nvPr>
+        </p:nvSpPr>
+        <p:spPr/>
+        <p:txBody>
+          <a:bodyPr/>
+          <a:lstStyle/>
+          <a:p>
+            <a:r>
+              <a:rPr lang="en-US" dirty="0"/>
+              <a:t/>
+            </a:r>
+            <a:endParaRPr lang="en-US" dirty="0"/>
+          </a:p>
+        </p:txBody>
+      </p:sp>
+      <p:sp>
+        <p:nvSpPr>
+          <p:cNvPr id="4" name="Slide Number Placeholder 3"/>
+          <p:cNvSpPr>
+            <a:spLocks noGrp="1"/>
+          </p:cNvSpPr>
+          <p:nvPr>
+            <p:ph type="sldNum" sz="quarter" idx="10"/>
+          </p:nvPr>
+        </p:nvSpPr>
+        <p:spPr/>
+        <p:txBody>
+          <a:bodyPr/>
+          <a:lstStyle/>
+          <a:p>
+            <a:fld id="{F7021451-1387-4CA6-816F-3879F97B5CBC}" type="slidenum">
+              <a:rPr lang="en-US"/>
+              <a:t>25</a:t>
             </a:fld>
             <a:endParaRPr lang="en-US"/>
           </a:p>
@@ -8370,8 +8640,8 @@
         </p:nvSpPr>
         <p:spPr>
           <a:xfrm>
-            <a:off x="548640" y="1691640"/>
-            <a:ext cx="11091672" cy="4663440"/>
+            <a:off x="548640" y="1645920"/>
+            <a:ext cx="5413248" cy="4754880"/>
           </a:xfrm>
           <a:prstGeom prst="rect">
             <a:avLst/>
@@ -8385,104 +8655,324 @@
           <a:p>
             <a:pPr indent="0" marL="0">
               <a:spcAft>
-                <a:spcPts val="1000"/>
+                <a:spcPts val="600"/>
               </a:spcAft>
               <a:buNone/>
             </a:pPr>
             <a:r>
-              <a:rPr lang="en-US" sz="1600" dirty="0">
-                <a:solidFill>
-                  <a:schemeClr val="tx1"/>
-                </a:solidFill>
-              </a:rPr>
-              <a:t>Allal-Chérif, O., Puertas, R., &amp; Carracedo, P. (2024). Intelligent influencer marketing: How AI-powered virtual influencers outperform human influencers. Technological Forecasting and Social Change, 200, 123113.</a:t>
-            </a:r>
-            <a:endParaRPr lang="en-US" sz="1600" dirty="0"/>
+              <a:rPr lang="en-US" sz="1300" b="1" dirty="0">
+                <a:solidFill>
+                  <a:schemeClr val="accent4"/>
+                </a:solidFill>
+              </a:rPr>
+              <a:t>1. </a:t>
+            </a:r>
+            <a:r>
+              <a:rPr lang="en-US" sz="1300" dirty="0">
+                <a:solidFill>
+                  <a:schemeClr val="tx1"/>
+                </a:solidFill>
+              </a:rPr>
+              <a:t>Ajzen, I. (1991). The theory of planned behavior. Organizational Behavior and Human Decision Processes, 50(2), 179–211.</a:t>
+            </a:r>
+            <a:endParaRPr lang="en-US" sz="1300" dirty="0"/>
           </a:p>
           <a:p>
             <a:pPr indent="0" marL="0">
               <a:spcAft>
-                <a:spcPts val="1000"/>
+                <a:spcPts val="600"/>
               </a:spcAft>
               <a:buNone/>
             </a:pPr>
             <a:r>
-              <a:rPr lang="en-US" sz="1600" dirty="0">
-                <a:solidFill>
-                  <a:schemeClr val="tx1"/>
-                </a:solidFill>
-              </a:rPr>
-              <a:t>Belanche, D., Casaló, L. V., &amp; Flavián, M. (2024). Human versus virtual influences, a comparative study. Journal of Business Research, 173, 114493.</a:t>
-            </a:r>
-            <a:endParaRPr lang="en-US" sz="1600" dirty="0"/>
+              <a:rPr lang="en-US" sz="1300" b="1" dirty="0">
+                <a:solidFill>
+                  <a:schemeClr val="accent4"/>
+                </a:solidFill>
+              </a:rPr>
+              <a:t>2. </a:t>
+            </a:r>
+            <a:r>
+              <a:rPr lang="en-US" sz="1300" dirty="0">
+                <a:solidFill>
+                  <a:schemeClr val="tx1"/>
+                </a:solidFill>
+              </a:rPr>
+              <a:t>Allal-Chérif, O., Puertas, R., &amp; Carracedo, P. (2024). Intelligent influencer marketing: How AI-powered virtual influencers outperform human influencers. Technological Forecasting and Social Change, 200, Article 123113.</a:t>
+            </a:r>
+            <a:endParaRPr lang="en-US" sz="1300" dirty="0"/>
           </a:p>
           <a:p>
             <a:pPr indent="0" marL="0">
               <a:spcAft>
-                <a:spcPts val="1000"/>
+                <a:spcPts val="600"/>
               </a:spcAft>
               <a:buNone/>
             </a:pPr>
             <a:r>
-              <a:rPr lang="en-US" sz="1600" dirty="0">
-                <a:solidFill>
-                  <a:schemeClr val="tx1"/>
-                </a:solidFill>
-              </a:rPr>
-              <a:t>Cascio Rizzo, G. L., Villarroel Ordenes, F., &amp; Berger, J. (2026). What drives virtual influencers' impact? Journal of the Academy of Marketing Science.</a:t>
-            </a:r>
-            <a:endParaRPr lang="en-US" sz="1600" dirty="0"/>
+              <a:rPr lang="en-US" sz="1300" b="1" dirty="0">
+                <a:solidFill>
+                  <a:schemeClr val="accent4"/>
+                </a:solidFill>
+              </a:rPr>
+              <a:t>3. </a:t>
+            </a:r>
+            <a:r>
+              <a:rPr lang="en-US" sz="1300" dirty="0">
+                <a:solidFill>
+                  <a:schemeClr val="tx1"/>
+                </a:solidFill>
+              </a:rPr>
+              <a:t>Arsenyan, J., &amp; Mirowska, A. (2021). Almost human? A comparative case study on the social media presence of virtual influencers. International Journal of Human-Computer Studies, 155, Article 102694.</a:t>
+            </a:r>
+            <a:endParaRPr lang="en-US" sz="1300" dirty="0"/>
           </a:p>
           <a:p>
             <a:pPr indent="0" marL="0">
               <a:spcAft>
-                <a:spcPts val="1000"/>
+                <a:spcPts val="600"/>
               </a:spcAft>
               <a:buNone/>
             </a:pPr>
             <a:r>
-              <a:rPr lang="en-US" sz="1600" dirty="0">
-                <a:solidFill>
-                  <a:schemeClr val="tx1"/>
-                </a:solidFill>
-              </a:rPr>
-              <a:t>Epley, N., Waytz, A., &amp; Cacioppo, J. T. (2007). On seeing human: A three-factor theory of anthropomorphism. Psychological Review, 114(4), 864–886.</a:t>
-            </a:r>
-            <a:endParaRPr lang="en-US" sz="1600" dirty="0"/>
+              <a:rPr lang="en-US" sz="1300" b="1" dirty="0">
+                <a:solidFill>
+                  <a:schemeClr val="accent4"/>
+                </a:solidFill>
+              </a:rPr>
+              <a:t>4. </a:t>
+            </a:r>
+            <a:r>
+              <a:rPr lang="en-US" sz="1300" dirty="0">
+                <a:solidFill>
+                  <a:schemeClr val="tx1"/>
+                </a:solidFill>
+              </a:rPr>
+              <a:t>Audrezet, A., de Kerviler, G., &amp; Guidry Moulard, J. (2020). Authenticity under threat: When social media influencers need to go beyond self-presentation. Journal of Business Research, 117, 557–569.</a:t>
+            </a:r>
+            <a:endParaRPr lang="en-US" sz="1300" dirty="0"/>
           </a:p>
           <a:p>
             <a:pPr indent="0" marL="0">
               <a:spcAft>
-                <a:spcPts val="1000"/>
+                <a:spcPts val="600"/>
               </a:spcAft>
               <a:buNone/>
             </a:pPr>
             <a:r>
-              <a:rPr lang="en-US" sz="1600" dirty="0">
-                <a:solidFill>
-                  <a:schemeClr val="tx1"/>
-                </a:solidFill>
-              </a:rPr>
-              <a:t>George, J. P., Muttungal, P. V., Priya, N., &amp; Davidson, B. G. J. (2026). Credibility, engagement, and purchase: How virtual influencers drive Gen Zs consumer behavior. Emerald Publishing.</a:t>
-            </a:r>
-            <a:endParaRPr lang="en-US" sz="1600" dirty="0"/>
+              <a:rPr lang="en-US" sz="1300" b="1" dirty="0">
+                <a:solidFill>
+                  <a:schemeClr val="accent4"/>
+                </a:solidFill>
+              </a:rPr>
+              <a:t>5. </a:t>
+            </a:r>
+            <a:r>
+              <a:rPr lang="en-US" sz="1300" dirty="0">
+                <a:solidFill>
+                  <a:schemeClr val="tx1"/>
+                </a:solidFill>
+              </a:rPr>
+              <a:t>Bartneck, C., Kulić, D., Croft, E., &amp; Zoghbi, S. (2009). Measurement instruments for the anthropomorphism, animacy, likeability, perceived intelligence, and perceived safety of robots. International Journal of Social Robotics, 1(1), 71–81.</a:t>
+            </a:r>
+            <a:endParaRPr lang="en-US" sz="1300" dirty="0"/>
           </a:p>
           <a:p>
             <a:pPr indent="0" marL="0">
               <a:spcAft>
-                <a:spcPts val="1000"/>
+                <a:spcPts val="600"/>
               </a:spcAft>
               <a:buNone/>
             </a:pPr>
             <a:r>
-              <a:rPr lang="en-US" sz="1600" dirty="0">
-                <a:solidFill>
-                  <a:schemeClr val="tx1"/>
-                </a:solidFill>
-              </a:rPr>
-              <a:t>Gerlich, M. (2023). The power of virtual influencers: Impact on consumer behaviour and attitudes in the age of AI. Administrative Sciences, 13(8), 178.</a:t>
-            </a:r>
-            <a:endParaRPr lang="en-US" sz="1600" dirty="0"/>
+              <a:rPr lang="en-US" sz="1300" b="1" dirty="0">
+                <a:solidFill>
+                  <a:schemeClr val="accent4"/>
+                </a:solidFill>
+              </a:rPr>
+              <a:t>6. </a:t>
+            </a:r>
+            <a:r>
+              <a:rPr lang="en-US" sz="1300" dirty="0">
+                <a:solidFill>
+                  <a:schemeClr val="tx1"/>
+                </a:solidFill>
+              </a:rPr>
+              <a:t>Belanche, D., Casaló, L. V., &amp; Flavián, M. (2024). Human versus virtual influences, a comparative study. Journal of Business Research, 173, Article 114493.</a:t>
+            </a:r>
+            <a:endParaRPr lang="en-US" sz="1300" dirty="0"/>
+          </a:p>
+        </p:txBody>
+      </p:sp>
+      <p:sp>
+        <p:nvSpPr>
+          <p:cNvPr id="4" name="Text 2"/>
+          <p:cNvSpPr txBox="1"/>
+          <p:nvPr/>
+        </p:nvSpPr>
+        <p:spPr>
+          <a:xfrm>
+            <a:off x="6227064" y="1645920"/>
+            <a:ext cx="5413248" cy="4754880"/>
+          </a:xfrm>
+          <a:prstGeom prst="rect">
+            <a:avLst/>
+          </a:prstGeom>
+          <a:noFill/>
+          <a:ln/>
+        </p:spPr>
+        <p:txBody>
+          <a:bodyPr wrap="square" lIns="0" tIns="0" rIns="0" bIns="0" rtlCol="0" anchor="t"/>
+          <a:lstStyle/>
+          <a:p>
+            <a:pPr indent="0" marL="0">
+              <a:spcAft>
+                <a:spcPts val="600"/>
+              </a:spcAft>
+              <a:buNone/>
+            </a:pPr>
+            <a:r>
+              <a:rPr lang="en-US" sz="1300" b="1" dirty="0">
+                <a:solidFill>
+                  <a:schemeClr val="accent4"/>
+                </a:solidFill>
+              </a:rPr>
+              <a:t>7. </a:t>
+            </a:r>
+            <a:r>
+              <a:rPr lang="en-US" sz="1300" dirty="0">
+                <a:solidFill>
+                  <a:schemeClr val="tx1"/>
+                </a:solidFill>
+              </a:rPr>
+              <a:t>Byun, K. J., &amp; Ahn, S. J. (2023). A systematic review of virtual influencers: Similarities and differences between human and virtual influencers in interactive advertising. Journal of Interactive Advertising, 23(4), 293–306.</a:t>
+            </a:r>
+            <a:endParaRPr lang="en-US" sz="1300" dirty="0"/>
+          </a:p>
+          <a:p>
+            <a:pPr indent="0" marL="0">
+              <a:spcAft>
+                <a:spcPts val="600"/>
+              </a:spcAft>
+              <a:buNone/>
+            </a:pPr>
+            <a:r>
+              <a:rPr lang="en-US" sz="1300" b="1" dirty="0">
+                <a:solidFill>
+                  <a:schemeClr val="accent4"/>
+                </a:solidFill>
+              </a:rPr>
+              <a:t>8. </a:t>
+            </a:r>
+            <a:r>
+              <a:rPr lang="en-US" sz="1300" dirty="0">
+                <a:solidFill>
+                  <a:schemeClr val="tx1"/>
+                </a:solidFill>
+              </a:rPr>
+              <a:t>Campbell, C., &amp; Farrell, J. R. (2020). More than meets the eye: The functional components underlying influencer marketing. Business Horizons, 63(4), 469–479.</a:t>
+            </a:r>
+            <a:endParaRPr lang="en-US" sz="1300" dirty="0"/>
+          </a:p>
+          <a:p>
+            <a:pPr indent="0" marL="0">
+              <a:spcAft>
+                <a:spcPts val="600"/>
+              </a:spcAft>
+              <a:buNone/>
+            </a:pPr>
+            <a:r>
+              <a:rPr lang="en-US" sz="1300" b="1" dirty="0">
+                <a:solidFill>
+                  <a:schemeClr val="accent4"/>
+                </a:solidFill>
+              </a:rPr>
+              <a:t>9. </a:t>
+            </a:r>
+            <a:r>
+              <a:rPr lang="en-US" sz="1300" dirty="0">
+                <a:solidFill>
+                  <a:schemeClr val="tx1"/>
+                </a:solidFill>
+              </a:rPr>
+              <a:t>Cascio Rizzo, G. L., Villarroel Ordenes, F., &amp; Berger, J. (2026). What drives virtual influencers' impact? Journal of the Academy of Marketing Science.</a:t>
+            </a:r>
+            <a:endParaRPr lang="en-US" sz="1300" dirty="0"/>
+          </a:p>
+          <a:p>
+            <a:pPr indent="0" marL="0">
+              <a:spcAft>
+                <a:spcPts val="600"/>
+              </a:spcAft>
+              <a:buNone/>
+            </a:pPr>
+            <a:r>
+              <a:rPr lang="en-US" sz="1300" b="1" dirty="0">
+                <a:solidFill>
+                  <a:schemeClr val="accent4"/>
+                </a:solidFill>
+              </a:rPr>
+              <a:t>10. </a:t>
+            </a:r>
+            <a:r>
+              <a:rPr lang="en-US" sz="1300" dirty="0">
+                <a:solidFill>
+                  <a:schemeClr val="tx1"/>
+                </a:solidFill>
+              </a:rPr>
+              <a:t>Chaudhuri, A., &amp; Holbrook, M. B. (2001). The chain of effects from brand trust and brand affect to brand performance: The role of brand loyalty. Journal of Marketing, 65(2), 81–93.</a:t>
+            </a:r>
+            <a:endParaRPr lang="en-US" sz="1300" dirty="0"/>
+          </a:p>
+          <a:p>
+            <a:pPr indent="0" marL="0">
+              <a:spcAft>
+                <a:spcPts val="600"/>
+              </a:spcAft>
+              <a:buNone/>
+            </a:pPr>
+            <a:r>
+              <a:rPr lang="en-US" sz="1300" b="1" dirty="0">
+                <a:solidFill>
+                  <a:schemeClr val="accent4"/>
+                </a:solidFill>
+              </a:rPr>
+              <a:t>11. </a:t>
+            </a:r>
+            <a:r>
+              <a:rPr lang="en-US" sz="1300" dirty="0">
+                <a:solidFill>
+                  <a:schemeClr val="tx1"/>
+                </a:solidFill>
+              </a:rPr>
+              <a:t>Crolic, C., Thomaz, F., Hadi, R., &amp; Stephen, A. T. (2022). Blame the bot: Anthropomorphism and anger in customer–chatbot interactions. Journal of Marketing, 86(1), 132–148.</a:t>
+            </a:r>
+            <a:endParaRPr lang="en-US" sz="1300" dirty="0"/>
+          </a:p>
+          <a:p>
+            <a:pPr indent="0" marL="0">
+              <a:spcAft>
+                <a:spcPts val="600"/>
+              </a:spcAft>
+              <a:buNone/>
+            </a:pPr>
+            <a:r>
+              <a:rPr lang="en-US" sz="1300" b="1" dirty="0">
+                <a:solidFill>
+                  <a:schemeClr val="accent4"/>
+                </a:solidFill>
+              </a:rPr>
+              <a:t>12. </a:t>
+            </a:r>
+            <a:r>
+              <a:rPr lang="en-US" sz="1300" dirty="0">
+                <a:solidFill>
+                  <a:schemeClr val="tx1"/>
+                </a:solidFill>
+              </a:rPr>
+              <a:t>Davlembayeva, D., Chari, S., &amp; Papagiannidis, S. (2025). Virtual influencers in consumer behaviour: A social influence theory perspective. British Journal of Management, 36(1), 202–222.</a:t>
+            </a:r>
+            <a:endParaRPr lang="en-US" sz="1300" dirty="0"/>
           </a:p>
         </p:txBody>
       </p:sp>
@@ -8974,8 +9464,8 @@
         </p:nvSpPr>
         <p:spPr>
           <a:xfrm>
-            <a:off x="548640" y="1691640"/>
-            <a:ext cx="11091672" cy="4663440"/>
+            <a:off x="548640" y="1645920"/>
+            <a:ext cx="5413248" cy="4754880"/>
           </a:xfrm>
           <a:prstGeom prst="rect">
             <a:avLst/>
@@ -8989,104 +9479,324 @@
           <a:p>
             <a:pPr indent="0" marL="0">
               <a:spcAft>
-                <a:spcPts val="1000"/>
+                <a:spcPts val="600"/>
               </a:spcAft>
               <a:buNone/>
             </a:pPr>
             <a:r>
-              <a:rPr lang="en-US" sz="1600" dirty="0">
-                <a:solidFill>
-                  <a:schemeClr val="tx1"/>
-                </a:solidFill>
-              </a:rPr>
-              <a:t>Jha, S., Chaudhary, R., &amp; Shukla, B. (2025). Trust dynamics of virtual influencers: Exploring their influence on fashion purchase decisions. Innovative Marketing, 21(3), 226–236.</a:t>
-            </a:r>
-            <a:endParaRPr lang="en-US" sz="1600" dirty="0"/>
+              <a:rPr lang="en-US" sz="1300" b="1" dirty="0">
+                <a:solidFill>
+                  <a:schemeClr val="accent4"/>
+                </a:solidFill>
+              </a:rPr>
+              <a:t>13. </a:t>
+            </a:r>
+            <a:r>
+              <a:rPr lang="en-US" sz="1300" dirty="0">
+                <a:solidFill>
+                  <a:schemeClr val="tx1"/>
+                </a:solidFill>
+              </a:rPr>
+              <a:t>Djafarova, E., &amp; Bowes, T. (2021). 'Instagram made me buy it': Generation Z impulse purchases in fashion industry. Journal of Retailing and Consumer Services, 59, Article 102345.</a:t>
+            </a:r>
+            <a:endParaRPr lang="en-US" sz="1300" dirty="0"/>
           </a:p>
           <a:p>
             <a:pPr indent="0" marL="0">
               <a:spcAft>
-                <a:spcPts val="1000"/>
+                <a:spcPts val="600"/>
               </a:spcAft>
               <a:buNone/>
             </a:pPr>
             <a:r>
-              <a:rPr lang="en-US" sz="1600" dirty="0">
-                <a:solidFill>
-                  <a:schemeClr val="tx1"/>
-                </a:solidFill>
-              </a:rPr>
-              <a:t>Lee, J. A., &amp; Eastin, M. S. (2021). Perceived authenticity of social media influencers: Scale development and validation. Journal of Research in Interactive Marketing, 15(4), 822–841.</a:t>
-            </a:r>
-            <a:endParaRPr lang="en-US" sz="1600" dirty="0"/>
+              <a:rPr lang="en-US" sz="1300" b="1" dirty="0">
+                <a:solidFill>
+                  <a:schemeClr val="accent4"/>
+                </a:solidFill>
+              </a:rPr>
+              <a:t>14. </a:t>
+            </a:r>
+            <a:r>
+              <a:rPr lang="en-US" sz="1300" dirty="0">
+                <a:solidFill>
+                  <a:schemeClr val="tx1"/>
+                </a:solidFill>
+              </a:rPr>
+              <a:t>Djafarova, E., &amp; Rushworth, C. (2017). Exploring the credibility of online celebrities' Instagram profiles in influencing the purchase decisions of young female users. Computers in Human Behavior, 68, 1–7.</a:t>
+            </a:r>
+            <a:endParaRPr lang="en-US" sz="1300" dirty="0"/>
           </a:p>
           <a:p>
             <a:pPr indent="0" marL="0">
               <a:spcAft>
-                <a:spcPts val="1000"/>
+                <a:spcPts val="600"/>
               </a:spcAft>
               <a:buNone/>
             </a:pPr>
             <a:r>
-              <a:rPr lang="en-US" sz="1600" dirty="0">
-                <a:solidFill>
-                  <a:schemeClr val="tx1"/>
-                </a:solidFill>
-              </a:rPr>
-              <a:t>Lonsdale, N., Aydin, G., &amp; Magtibay, R. (2025). Anthropomorphism and diversity in virtual humans: Their influence on the trust and attitudes of Gen Z consumers. Corporate Communications, 30(5), 888–914.</a:t>
-            </a:r>
-            <a:endParaRPr lang="en-US" sz="1600" dirty="0"/>
+              <a:rPr lang="en-US" sz="1300" b="1" dirty="0">
+                <a:solidFill>
+                  <a:schemeClr val="accent4"/>
+                </a:solidFill>
+              </a:rPr>
+              <a:t>15. </a:t>
+            </a:r>
+            <a:r>
+              <a:rPr lang="en-US" sz="1300" dirty="0">
+                <a:solidFill>
+                  <a:schemeClr val="tx1"/>
+                </a:solidFill>
+              </a:rPr>
+              <a:t>Epley, N., Waytz, A., &amp; Cacioppo, J. T. (2007). On seeing human: A three-factor theory of anthropomorphism. Psychological Review, 114(4), 864–886.</a:t>
+            </a:r>
+            <a:endParaRPr lang="en-US" sz="1300" dirty="0"/>
           </a:p>
           <a:p>
             <a:pPr indent="0" marL="0">
               <a:spcAft>
-                <a:spcPts val="1000"/>
+                <a:spcPts val="600"/>
               </a:spcAft>
               <a:buNone/>
             </a:pPr>
             <a:r>
-              <a:rPr lang="en-US" sz="1600" dirty="0">
-                <a:solidFill>
-                  <a:schemeClr val="tx1"/>
-                </a:solidFill>
-              </a:rPr>
-              <a:t>Lou, C., Kiew, S. T. J., Chen, T., Lee, T. Y. M., Ong, J. E. C., &amp; Phua, Z. (2023). Authentically fake? How consumers respond to the influence of virtual influencers. Journal of Advertising, 52(4), 540–557.</a:t>
-            </a:r>
-            <a:endParaRPr lang="en-US" sz="1600" dirty="0"/>
+              <a:rPr lang="en-US" sz="1300" b="1" dirty="0">
+                <a:solidFill>
+                  <a:schemeClr val="accent4"/>
+                </a:solidFill>
+              </a:rPr>
+              <a:t>16. </a:t>
+            </a:r>
+            <a:r>
+              <a:rPr lang="en-US" sz="1300" dirty="0">
+                <a:solidFill>
+                  <a:schemeClr val="tx1"/>
+                </a:solidFill>
+              </a:rPr>
+              <a:t>Eroglu, S. A., Machleit, K. A., &amp; Davis, L. M. (2001). Atmospheric qualities of online retailing: A conceptual model and implications. Journal of Business Research, 54(2), 177–184.</a:t>
+            </a:r>
+            <a:endParaRPr lang="en-US" sz="1300" dirty="0"/>
           </a:p>
           <a:p>
             <a:pPr indent="0" marL="0">
               <a:spcAft>
-                <a:spcPts val="1000"/>
+                <a:spcPts val="600"/>
               </a:spcAft>
               <a:buNone/>
             </a:pPr>
             <a:r>
-              <a:rPr lang="en-US" sz="1600" dirty="0">
-                <a:solidFill>
-                  <a:schemeClr val="tx1"/>
-                </a:solidFill>
-              </a:rPr>
-              <a:t>Lou, C., &amp; Yuan, S. (2019). Influencer marketing: How message value and credibility affect consumer trust of branded content on social media. Journal of Interactive Advertising, 19(1), 58–73.</a:t>
-            </a:r>
-            <a:endParaRPr lang="en-US" sz="1600" dirty="0"/>
+              <a:rPr lang="en-US" sz="1300" b="1" dirty="0">
+                <a:solidFill>
+                  <a:schemeClr val="accent4"/>
+                </a:solidFill>
+              </a:rPr>
+              <a:t>17. </a:t>
+            </a:r>
+            <a:r>
+              <a:rPr lang="en-US" sz="1300" dirty="0">
+                <a:solidFill>
+                  <a:schemeClr val="tx1"/>
+                </a:solidFill>
+              </a:rPr>
+              <a:t>Franke, C., Groeppel-Klein, A., &amp; Müller, K. (2023). Consumers' responses to virtual influencers as advertising endorsers: Novel and effective or uncanny and deceiving? Journal of Advertising, 52(4), 523–539.</a:t>
+            </a:r>
+            <a:endParaRPr lang="en-US" sz="1300" dirty="0"/>
           </a:p>
           <a:p>
             <a:pPr indent="0" marL="0">
               <a:spcAft>
-                <a:spcPts val="1000"/>
+                <a:spcPts val="600"/>
               </a:spcAft>
               <a:buNone/>
             </a:pPr>
             <a:r>
-              <a:rPr lang="en-US" sz="1600" dirty="0">
-                <a:solidFill>
-                  <a:schemeClr val="tx1"/>
-                </a:solidFill>
-              </a:rPr>
-              <a:t>Mayer, R. C., Davis, J. H., &amp; Schoorman, F. D. (1995). An integrative model of organizational trust. Academy of Management Review, 20(3), 709–734.</a:t>
-            </a:r>
-            <a:endParaRPr lang="en-US" sz="1600" dirty="0"/>
+              <a:rPr lang="en-US" sz="1300" b="1" dirty="0">
+                <a:solidFill>
+                  <a:schemeClr val="accent4"/>
+                </a:solidFill>
+              </a:rPr>
+              <a:t>18. </a:t>
+            </a:r>
+            <a:r>
+              <a:rPr lang="en-US" sz="1300" dirty="0">
+                <a:solidFill>
+                  <a:schemeClr val="tx1"/>
+                </a:solidFill>
+              </a:rPr>
+              <a:t>George, J. P., Muttungal, P. V., Priya, N., &amp; Davidson, B. G. J. (2026). Credibility, engagement, and purchase: How virtual influencers drive Gen Zs consumer behavior. In A. Saini &amp; V. Garg (Eds.), Industry 5.0: Pioneering business and management transformations (pp. 119–134). Emerald Publishing.</a:t>
+            </a:r>
+            <a:endParaRPr lang="en-US" sz="1300" dirty="0"/>
+          </a:p>
+        </p:txBody>
+      </p:sp>
+      <p:sp>
+        <p:nvSpPr>
+          <p:cNvPr id="4" name="Text 2"/>
+          <p:cNvSpPr txBox="1"/>
+          <p:nvPr/>
+        </p:nvSpPr>
+        <p:spPr>
+          <a:xfrm>
+            <a:off x="6227064" y="1645920"/>
+            <a:ext cx="5413248" cy="4754880"/>
+          </a:xfrm>
+          <a:prstGeom prst="rect">
+            <a:avLst/>
+          </a:prstGeom>
+          <a:noFill/>
+          <a:ln/>
+        </p:spPr>
+        <p:txBody>
+          <a:bodyPr wrap="square" lIns="0" tIns="0" rIns="0" bIns="0" rtlCol="0" anchor="t"/>
+          <a:lstStyle/>
+          <a:p>
+            <a:pPr indent="0" marL="0">
+              <a:spcAft>
+                <a:spcPts val="600"/>
+              </a:spcAft>
+              <a:buNone/>
+            </a:pPr>
+            <a:r>
+              <a:rPr lang="en-US" sz="1300" b="1" dirty="0">
+                <a:solidFill>
+                  <a:schemeClr val="accent4"/>
+                </a:solidFill>
+              </a:rPr>
+              <a:t>19. </a:t>
+            </a:r>
+            <a:r>
+              <a:rPr lang="en-US" sz="1300" dirty="0">
+                <a:solidFill>
+                  <a:schemeClr val="tx1"/>
+                </a:solidFill>
+              </a:rPr>
+              <a:t>Gerlich, M. (2023). The power of virtual influencers: Impact on consumer behaviour and attitudes in the age of AI. Administrative Sciences, 13(8), Article 178.</a:t>
+            </a:r>
+            <a:endParaRPr lang="en-US" sz="1300" dirty="0"/>
+          </a:p>
+          <a:p>
+            <a:pPr indent="0" marL="0">
+              <a:spcAft>
+                <a:spcPts val="600"/>
+              </a:spcAft>
+              <a:buNone/>
+            </a:pPr>
+            <a:r>
+              <a:rPr lang="en-US" sz="1300" b="1" dirty="0">
+                <a:solidFill>
+                  <a:schemeClr val="accent4"/>
+                </a:solidFill>
+              </a:rPr>
+              <a:t>20. </a:t>
+            </a:r>
+            <a:r>
+              <a:rPr lang="en-US" sz="1300" dirty="0">
+                <a:solidFill>
+                  <a:schemeClr val="tx1"/>
+                </a:solidFill>
+              </a:rPr>
+              <a:t>Gerrath, M. H., Olya, H., Shah, Z., &amp; Li, H. (2024). Virtual influencers and pro-environmental causes: The roles of message warmth and trust in experts. Journal of Business Research, 175, Article 114520.</a:t>
+            </a:r>
+            <a:endParaRPr lang="en-US" sz="1300" dirty="0"/>
+          </a:p>
+          <a:p>
+            <a:pPr indent="0" marL="0">
+              <a:spcAft>
+                <a:spcPts val="600"/>
+              </a:spcAft>
+              <a:buNone/>
+            </a:pPr>
+            <a:r>
+              <a:rPr lang="en-US" sz="1300" b="1" dirty="0">
+                <a:solidFill>
+                  <a:schemeClr val="accent4"/>
+                </a:solidFill>
+              </a:rPr>
+              <a:t>21. </a:t>
+            </a:r>
+            <a:r>
+              <a:rPr lang="en-US" sz="1300" dirty="0">
+                <a:solidFill>
+                  <a:schemeClr val="tx1"/>
+                </a:solidFill>
+              </a:rPr>
+              <a:t>Gutuleac, R., Baima, G., Rizzo, C., &amp; Bresciani, S. (2024). Will virtual influencers overcome the uncanny valley? The moderating role of social cues. Psychology &amp; Marketing, 41(7), 1419–1431.</a:t>
+            </a:r>
+            <a:endParaRPr lang="en-US" sz="1300" dirty="0"/>
+          </a:p>
+          <a:p>
+            <a:pPr indent="0" marL="0">
+              <a:spcAft>
+                <a:spcPts val="600"/>
+              </a:spcAft>
+              <a:buNone/>
+            </a:pPr>
+            <a:r>
+              <a:rPr lang="en-US" sz="1300" b="1" dirty="0">
+                <a:solidFill>
+                  <a:schemeClr val="accent4"/>
+                </a:solidFill>
+              </a:rPr>
+              <a:t>22. </a:t>
+            </a:r>
+            <a:r>
+              <a:rPr lang="en-US" sz="1300" dirty="0">
+                <a:solidFill>
+                  <a:schemeClr val="tx1"/>
+                </a:solidFill>
+              </a:rPr>
+              <a:t>Han, J., &amp; Balabanis, G. (2024). Meta-analysis of social media influencer impact: Key antecedents and theoretical foundations. Psychology &amp; Marketing, 41(2), 394–426.</a:t>
+            </a:r>
+            <a:endParaRPr lang="en-US" sz="1300" dirty="0"/>
+          </a:p>
+          <a:p>
+            <a:pPr indent="0" marL="0">
+              <a:spcAft>
+                <a:spcPts val="600"/>
+              </a:spcAft>
+              <a:buNone/>
+            </a:pPr>
+            <a:r>
+              <a:rPr lang="en-US" sz="1300" b="1" dirty="0">
+                <a:solidFill>
+                  <a:schemeClr val="accent4"/>
+                </a:solidFill>
+              </a:rPr>
+              <a:t>23. </a:t>
+            </a:r>
+            <a:r>
+              <a:rPr lang="en-US" sz="1300" dirty="0">
+                <a:solidFill>
+                  <a:schemeClr val="tx1"/>
+                </a:solidFill>
+              </a:rPr>
+              <a:t>Hovland, C. I., &amp; Weiss, W. (1951). The influence of source credibility on communication effectiveness. Public Opinion Quarterly, 15(4), 635–650.</a:t>
+            </a:r>
+            <a:endParaRPr lang="en-US" sz="1300" dirty="0"/>
+          </a:p>
+          <a:p>
+            <a:pPr indent="0" marL="0">
+              <a:spcAft>
+                <a:spcPts val="600"/>
+              </a:spcAft>
+              <a:buNone/>
+            </a:pPr>
+            <a:r>
+              <a:rPr lang="en-US" sz="1300" b="1" dirty="0">
+                <a:solidFill>
+                  <a:schemeClr val="accent4"/>
+                </a:solidFill>
+              </a:rPr>
+              <a:t>24. </a:t>
+            </a:r>
+            <a:r>
+              <a:rPr lang="en-US" sz="1300" dirty="0">
+                <a:solidFill>
+                  <a:schemeClr val="tx1"/>
+                </a:solidFill>
+              </a:rPr>
+              <a:t>Hudders, L., De Jans, S., &amp; De Veirman, M. (2021). The commercialization of social media stars: A literature review and conceptual framework on the strategic use of social media influencers. International Journal of Advertising, 40(3), 327–375.</a:t>
+            </a:r>
+            <a:endParaRPr lang="en-US" sz="1300" dirty="0"/>
           </a:p>
         </p:txBody>
       </p:sp>
@@ -9206,8 +9916,8 @@
         </p:nvSpPr>
         <p:spPr>
           <a:xfrm>
-            <a:off x="548640" y="1691640"/>
-            <a:ext cx="11091672" cy="4663440"/>
+            <a:off x="548640" y="1645920"/>
+            <a:ext cx="5413248" cy="4754880"/>
           </a:xfrm>
           <a:prstGeom prst="rect">
             <a:avLst/>
@@ -9221,104 +9931,324 @@
           <a:p>
             <a:pPr indent="0" marL="0">
               <a:spcAft>
-                <a:spcPts val="1000"/>
+                <a:spcPts val="600"/>
               </a:spcAft>
               <a:buNone/>
             </a:pPr>
             <a:r>
-              <a:rPr lang="en-US" sz="1600" dirty="0">
-                <a:solidFill>
-                  <a:schemeClr val="tx1"/>
-                </a:solidFill>
-              </a:rPr>
-              <a:t>McCroskey, J. C., Richmond, V. P., &amp; Daly, J. A. (1975). The development of a measure of perceived homophily in interpersonal communication. Human Communication Research, 1(4), 323–332.</a:t>
-            </a:r>
-            <a:endParaRPr lang="en-US" sz="1600" dirty="0"/>
+              <a:rPr lang="en-US" sz="1300" b="1" dirty="0">
+                <a:solidFill>
+                  <a:schemeClr val="accent4"/>
+                </a:solidFill>
+              </a:rPr>
+              <a:t>25. </a:t>
+            </a:r>
+            <a:r>
+              <a:rPr lang="en-US" sz="1300" dirty="0">
+                <a:solidFill>
+                  <a:schemeClr val="tx1"/>
+                </a:solidFill>
+              </a:rPr>
+              <a:t>Jha, S., Chaudhary, R., &amp; Shukla, B. (2025). Trust dynamics of virtual influencers: Exploring their influence on fashion purchase decisions. Innovative Marketing, 21(3), 226–236.</a:t>
+            </a:r>
+            <a:endParaRPr lang="en-US" sz="1300" dirty="0"/>
           </a:p>
           <a:p>
             <a:pPr indent="0" marL="0">
               <a:spcAft>
-                <a:spcPts val="1000"/>
+                <a:spcPts val="600"/>
               </a:spcAft>
               <a:buNone/>
             </a:pPr>
             <a:r>
-              <a:rPr lang="en-US" sz="1600" dirty="0">
-                <a:solidFill>
-                  <a:schemeClr val="tx1"/>
-                </a:solidFill>
-              </a:rPr>
-              <a:t>Mehrabian, A., &amp; Russell, J. A. (1974). An approach to environmental psychology. MIT Press.</a:t>
-            </a:r>
-            <a:endParaRPr lang="en-US" sz="1600" dirty="0"/>
+              <a:rPr lang="en-US" sz="1300" b="1" dirty="0">
+                <a:solidFill>
+                  <a:schemeClr val="accent4"/>
+                </a:solidFill>
+              </a:rPr>
+              <a:t>26. </a:t>
+            </a:r>
+            <a:r>
+              <a:rPr lang="en-US" sz="1300" dirty="0">
+                <a:solidFill>
+                  <a:schemeClr val="tx1"/>
+                </a:solidFill>
+              </a:rPr>
+              <a:t>Jhawar, A., Kumar, P., &amp; Varshney, S. (2023). The emergence of virtual influencers: A shift in the influencer marketing paradigm. Young Consumers, 24(4), 468–484.</a:t>
+            </a:r>
+            <a:endParaRPr lang="en-US" sz="1300" dirty="0"/>
           </a:p>
           <a:p>
             <a:pPr indent="0" marL="0">
               <a:spcAft>
-                <a:spcPts val="1000"/>
+                <a:spcPts val="600"/>
               </a:spcAft>
               <a:buNone/>
             </a:pPr>
             <a:r>
-              <a:rPr lang="en-US" sz="1600" dirty="0">
-                <a:solidFill>
-                  <a:schemeClr val="tx1"/>
-                </a:solidFill>
-              </a:rPr>
-              <a:t>Ohanian, R. (1990). Construction and validation of a scale to measure celebrity endorsers' perceived expertise, trustworthiness, and attractiveness. Journal of Advertising, 19(3), 39–52.</a:t>
-            </a:r>
-            <a:endParaRPr lang="en-US" sz="1600" dirty="0"/>
+              <a:rPr lang="en-US" sz="1300" b="1" dirty="0">
+                <a:solidFill>
+                  <a:schemeClr val="accent4"/>
+                </a:solidFill>
+              </a:rPr>
+              <a:t>27. </a:t>
+            </a:r>
+            <a:r>
+              <a:rPr lang="en-US" sz="1300" dirty="0">
+                <a:solidFill>
+                  <a:schemeClr val="tx1"/>
+                </a:solidFill>
+              </a:rPr>
+              <a:t>Kahle, L. R., &amp; Homer, P. M. (1985). Physical attractiveness of the celebrity endorser: A social adaptation perspective. Journal of Consumer Research, 11(4), 954–961.</a:t>
+            </a:r>
+            <a:endParaRPr lang="en-US" sz="1300" dirty="0"/>
           </a:p>
           <a:p>
             <a:pPr indent="0" marL="0">
               <a:spcAft>
-                <a:spcPts val="1000"/>
+                <a:spcPts val="600"/>
               </a:spcAft>
               <a:buNone/>
             </a:pPr>
             <a:r>
-              <a:rPr lang="en-US" sz="1600" dirty="0">
-                <a:solidFill>
-                  <a:schemeClr val="tx1"/>
-                </a:solidFill>
-              </a:rPr>
-              <a:t>Sands, S., Campbell, C. L., Plangger, K., &amp; Ferraro, C. (2022). Unreal influence: Leveraging AI in influencer marketing. European Journal of Marketing, 56(6), 1721–1747.</a:t>
-            </a:r>
-            <a:endParaRPr lang="en-US" sz="1600" dirty="0"/>
+              <a:rPr lang="en-US" sz="1300" b="1" dirty="0">
+                <a:solidFill>
+                  <a:schemeClr val="accent4"/>
+                </a:solidFill>
+              </a:rPr>
+              <a:t>28. </a:t>
+            </a:r>
+            <a:r>
+              <a:rPr lang="en-US" sz="1300" dirty="0">
+                <a:solidFill>
+                  <a:schemeClr val="tx1"/>
+                </a:solidFill>
+              </a:rPr>
+              <a:t>Khamis, S., Ang, L., &amp; Welling, R. (2017). Self-branding, 'micro-celebrity' and the rise of social media influencers. Celebrity Studies, 8(2), 191–208.</a:t>
+            </a:r>
+            <a:endParaRPr lang="en-US" sz="1300" dirty="0"/>
           </a:p>
           <a:p>
             <a:pPr indent="0" marL="0">
               <a:spcAft>
-                <a:spcPts val="1000"/>
+                <a:spcPts val="600"/>
               </a:spcAft>
               <a:buNone/>
             </a:pPr>
             <a:r>
-              <a:rPr lang="en-US" sz="1600" dirty="0">
-                <a:solidFill>
-                  <a:schemeClr val="tx1"/>
-                </a:solidFill>
-              </a:rPr>
-              <a:t>Spears, N., &amp; Singh, S. N. (2004). Measuring attitude toward the brand and purchase intentions. Journal of Current Issues &amp; Research in Advertising, 26(2), 53–66.</a:t>
-            </a:r>
-            <a:endParaRPr lang="en-US" sz="1600" dirty="0"/>
+              <a:rPr lang="en-US" sz="1300" b="1" dirty="0">
+                <a:solidFill>
+                  <a:schemeClr val="accent4"/>
+                </a:solidFill>
+              </a:rPr>
+              <a:t>29. </a:t>
+            </a:r>
+            <a:r>
+              <a:rPr lang="en-US" sz="1300" dirty="0">
+                <a:solidFill>
+                  <a:schemeClr val="tx1"/>
+                </a:solidFill>
+              </a:rPr>
+              <a:t>Kim, D. Y., &amp; Kim, H.-Y. (2021). Trust me, trust me not: A nuanced view of influencer marketing on social media. Journal of Business Research, 134, 223–232.</a:t>
+            </a:r>
+            <a:endParaRPr lang="en-US" sz="1300" dirty="0"/>
           </a:p>
           <a:p>
             <a:pPr indent="0" marL="0">
               <a:spcAft>
-                <a:spcPts val="1000"/>
+                <a:spcPts val="600"/>
               </a:spcAft>
               <a:buNone/>
             </a:pPr>
             <a:r>
-              <a:rPr lang="en-US" sz="1600" dirty="0">
-                <a:solidFill>
-                  <a:schemeClr val="tx1"/>
-                </a:solidFill>
-              </a:rPr>
-              <a:t>Stein, J.-P., Breves, P. L., &amp; Anders, N. (2024). Parasocial interactions with real and virtual influencers: The role of perceived similarity and human-likeness. New Media &amp; Society, 26(6), 3433–3453.</a:t>
-            </a:r>
-            <a:endParaRPr lang="en-US" sz="1600" dirty="0"/>
+              <a:rPr lang="en-US" sz="1300" b="1" dirty="0">
+                <a:solidFill>
+                  <a:schemeClr val="accent4"/>
+                </a:solidFill>
+              </a:rPr>
+              <a:t>30. </a:t>
+            </a:r>
+            <a:r>
+              <a:rPr lang="en-US" sz="1300" dirty="0">
+                <a:solidFill>
+                  <a:schemeClr val="tx1"/>
+                </a:solidFill>
+              </a:rPr>
+              <a:t>Kim, H., &amp; Park, M. (2023). Virtual influencers' attractiveness effect on purchase intention: A moderated mediation model of the product–endorser fit with the brand. Computers in Human Behavior, 143, Article 107703.</a:t>
+            </a:r>
+            <a:endParaRPr lang="en-US" sz="1300" dirty="0"/>
+          </a:p>
+        </p:txBody>
+      </p:sp>
+      <p:sp>
+        <p:nvSpPr>
+          <p:cNvPr id="4" name="Text 2"/>
+          <p:cNvSpPr txBox="1"/>
+          <p:nvPr/>
+        </p:nvSpPr>
+        <p:spPr>
+          <a:xfrm>
+            <a:off x="6227064" y="1645920"/>
+            <a:ext cx="5413248" cy="4754880"/>
+          </a:xfrm>
+          <a:prstGeom prst="rect">
+            <a:avLst/>
+          </a:prstGeom>
+          <a:noFill/>
+          <a:ln/>
+        </p:spPr>
+        <p:txBody>
+          <a:bodyPr wrap="square" lIns="0" tIns="0" rIns="0" bIns="0" rtlCol="0" anchor="t"/>
+          <a:lstStyle/>
+          <a:p>
+            <a:pPr indent="0" marL="0">
+              <a:spcAft>
+                <a:spcPts val="600"/>
+              </a:spcAft>
+              <a:buNone/>
+            </a:pPr>
+            <a:r>
+              <a:rPr lang="en-US" sz="1300" b="1" dirty="0">
+                <a:solidFill>
+                  <a:schemeClr val="accent4"/>
+                </a:solidFill>
+              </a:rPr>
+              <a:t>31. </a:t>
+            </a:r>
+            <a:r>
+              <a:rPr lang="en-US" sz="1300" dirty="0">
+                <a:solidFill>
+                  <a:schemeClr val="tx1"/>
+                </a:solidFill>
+              </a:rPr>
+              <a:t>Kim, I., Ki, C. W., Lee, H., &amp; Kim, Y. K. (2024). Virtual influencer marketing: Evaluating the influence of virtual influencers' form realism and behavioral realism on consumer ambivalence and marketing performance. Journal of Business Research, 176, Article 114611.</a:t>
+            </a:r>
+            <a:endParaRPr lang="en-US" sz="1300" dirty="0"/>
+          </a:p>
+          <a:p>
+            <a:pPr indent="0" marL="0">
+              <a:spcAft>
+                <a:spcPts val="600"/>
+              </a:spcAft>
+              <a:buNone/>
+            </a:pPr>
+            <a:r>
+              <a:rPr lang="en-US" sz="1300" b="1" dirty="0">
+                <a:solidFill>
+                  <a:schemeClr val="accent4"/>
+                </a:solidFill>
+              </a:rPr>
+              <a:t>32. </a:t>
+            </a:r>
+            <a:r>
+              <a:rPr lang="en-US" sz="1300" dirty="0">
+                <a:solidFill>
+                  <a:schemeClr val="tx1"/>
+                </a:solidFill>
+              </a:rPr>
+              <a:t>Ladhari, R., Massa, E., &amp; Skandrani, H. (2020). YouTube vloggers' popularity and influence: The roles of homophily, emotional attachment, and expertise. Journal of Retailing and Consumer Services, 54, Article 102027.</a:t>
+            </a:r>
+            <a:endParaRPr lang="en-US" sz="1300" dirty="0"/>
+          </a:p>
+          <a:p>
+            <a:pPr indent="0" marL="0">
+              <a:spcAft>
+                <a:spcPts val="600"/>
+              </a:spcAft>
+              <a:buNone/>
+            </a:pPr>
+            <a:r>
+              <a:rPr lang="en-US" sz="1300" b="1" dirty="0">
+                <a:solidFill>
+                  <a:schemeClr val="accent4"/>
+                </a:solidFill>
+              </a:rPr>
+              <a:t>33. </a:t>
+            </a:r>
+            <a:r>
+              <a:rPr lang="en-US" sz="1300" dirty="0">
+                <a:solidFill>
+                  <a:schemeClr val="tx1"/>
+                </a:solidFill>
+              </a:rPr>
+              <a:t>Lee, J. A., &amp; Eastin, M. S. (2021). Perceived authenticity of social media influencers: Scale development and validation. Journal of Research in Interactive Marketing, 15(4), 822–841.</a:t>
+            </a:r>
+            <a:endParaRPr lang="en-US" sz="1300" dirty="0"/>
+          </a:p>
+          <a:p>
+            <a:pPr indent="0" marL="0">
+              <a:spcAft>
+                <a:spcPts val="600"/>
+              </a:spcAft>
+              <a:buNone/>
+            </a:pPr>
+            <a:r>
+              <a:rPr lang="en-US" sz="1300" b="1" dirty="0">
+                <a:solidFill>
+                  <a:schemeClr val="accent4"/>
+                </a:solidFill>
+              </a:rPr>
+              <a:t>34. </a:t>
+            </a:r>
+            <a:r>
+              <a:rPr lang="en-US" sz="1300" dirty="0">
+                <a:solidFill>
+                  <a:schemeClr val="tx1"/>
+                </a:solidFill>
+              </a:rPr>
+              <a:t>Lee, J., &amp; Kim, H. (2025). The moderating role of homophily and need for uniqueness in the relationship between anthropomorphism of virtual influencer and intention to imitate and word of mouth. International Journal of Human–Computer Interaction, 41(17), 10911–10922.</a:t>
+            </a:r>
+            <a:endParaRPr lang="en-US" sz="1300" dirty="0"/>
+          </a:p>
+          <a:p>
+            <a:pPr indent="0" marL="0">
+              <a:spcAft>
+                <a:spcPts val="600"/>
+              </a:spcAft>
+              <a:buNone/>
+            </a:pPr>
+            <a:r>
+              <a:rPr lang="en-US" sz="1300" b="1" dirty="0">
+                <a:solidFill>
+                  <a:schemeClr val="accent4"/>
+                </a:solidFill>
+              </a:rPr>
+              <a:t>35. </a:t>
+            </a:r>
+            <a:r>
+              <a:rPr lang="en-US" sz="1300" dirty="0">
+                <a:solidFill>
+                  <a:schemeClr val="tx1"/>
+                </a:solidFill>
+              </a:rPr>
+              <a:t>Leung, F. F., Gu, F. F., &amp; Palmatier, R. W. (2022). Online influencer marketing. Journal of the Academy of Marketing Science, 50(2), 226–251.</a:t>
+            </a:r>
+            <a:endParaRPr lang="en-US" sz="1300" dirty="0"/>
+          </a:p>
+          <a:p>
+            <a:pPr indent="0" marL="0">
+              <a:spcAft>
+                <a:spcPts val="600"/>
+              </a:spcAft>
+              <a:buNone/>
+            </a:pPr>
+            <a:r>
+              <a:rPr lang="en-US" sz="1300" b="1" dirty="0">
+                <a:solidFill>
+                  <a:schemeClr val="accent4"/>
+                </a:solidFill>
+              </a:rPr>
+              <a:t>36. </a:t>
+            </a:r>
+            <a:r>
+              <a:rPr lang="en-US" sz="1300" dirty="0">
+                <a:solidFill>
+                  <a:schemeClr val="tx1"/>
+                </a:solidFill>
+              </a:rPr>
+              <a:t>Lin, Q., Li, Y., Li, L., &amp; Yu, X. (2025). Anthropomorphism effect of virtual influencers on purchase intention in social commerce: A presence perspective. Social Behavior and Personality: An International Journal, 53(2), Article e13953.</a:t>
+            </a:r>
+            <a:endParaRPr lang="en-US" sz="1300" dirty="0"/>
           </a:p>
         </p:txBody>
       </p:sp>
@@ -9378,6 +10308,1237 @@
 <file path=ppt/slides/slide22.xml><?xml version="1.0" encoding="utf-8"?>
 <p:sld xmlns:a="http://schemas.openxmlformats.org/drawingml/2006/main" xmlns:r="http://schemas.openxmlformats.org/officeDocument/2006/relationships" xmlns:p="http://schemas.openxmlformats.org/presentationml/2006/main">
   <p:cSld name="Slide 22">
+    <p:spTree>
+      <p:nvGrpSpPr>
+        <p:cNvPr id="1" name=""/>
+        <p:cNvGrpSpPr/>
+        <p:nvPr/>
+      </p:nvGrpSpPr>
+      <p:grpSpPr>
+        <a:xfrm>
+          <a:off x="0" y="0"/>
+          <a:ext cx="0" cy="0"/>
+          <a:chOff x="0" y="0"/>
+          <a:chExt cx="0" cy="0"/>
+        </a:xfrm>
+      </p:grpSpPr>
+      <p:sp>
+        <p:nvSpPr>
+          <p:cNvPr id="2" name="Text 3"/>
+          <p:cNvSpPr/>
+          <p:nvPr>
+            <p:ph idx="103" type="title" hasCustomPrompt="1"/>
+          </p:nvPr>
+        </p:nvSpPr>
+        <p:spPr>
+          <a:xfrm>
+            <a:off x="548640" y="749808"/>
+            <a:ext cx="11091672" cy="731520"/>
+          </a:xfrm>
+          <a:prstGeom prst="rect">
+            <a:avLst/>
+          </a:prstGeom>
+          <a:noFill/>
+          <a:ln/>
+        </p:spPr>
+        <p:txBody>
+          <a:bodyPr wrap="square" lIns="0" tIns="0" rIns="0" bIns="0" rtlCol="0" anchor="ctr"/>
+          <a:lstStyle/>
+          <a:p>
+            <a:pPr algn="l" indent="0" marL="0">
+              <a:buNone/>
+            </a:pPr>
+            <a:r>
+              <a:rPr lang="en-US" sz="2800" b="1" dirty="0">
+                <a:solidFill>
+                  <a:schemeClr val="tx1"/>
+                </a:solidFill>
+              </a:rPr>
+              <a:t>REFERENCES (CONTD.)</a:t>
+            </a:r>
+            <a:endParaRPr lang="en-US" sz="2800" dirty="0"/>
+          </a:p>
+        </p:txBody>
+      </p:sp>
+      <p:sp>
+        <p:nvSpPr>
+          <p:cNvPr id="3" name="Text 1"/>
+          <p:cNvSpPr txBox="1"/>
+          <p:nvPr/>
+        </p:nvSpPr>
+        <p:spPr>
+          <a:xfrm>
+            <a:off x="548640" y="1645920"/>
+            <a:ext cx="5413248" cy="4754880"/>
+          </a:xfrm>
+          <a:prstGeom prst="rect">
+            <a:avLst/>
+          </a:prstGeom>
+          <a:noFill/>
+          <a:ln/>
+        </p:spPr>
+        <p:txBody>
+          <a:bodyPr wrap="square" lIns="0" tIns="0" rIns="0" bIns="0" rtlCol="0" anchor="t"/>
+          <a:lstStyle/>
+          <a:p>
+            <a:pPr indent="0" marL="0">
+              <a:spcAft>
+                <a:spcPts val="600"/>
+              </a:spcAft>
+              <a:buNone/>
+            </a:pPr>
+            <a:r>
+              <a:rPr lang="en-US" sz="1300" b="1" dirty="0">
+                <a:solidFill>
+                  <a:schemeClr val="accent4"/>
+                </a:solidFill>
+              </a:rPr>
+              <a:t>37. </a:t>
+            </a:r>
+            <a:r>
+              <a:rPr lang="en-US" sz="1300" dirty="0">
+                <a:solidFill>
+                  <a:schemeClr val="tx1"/>
+                </a:solidFill>
+              </a:rPr>
+              <a:t>Lonsdale, N., Aydin, G., &amp; Magtibay, R. (2025). Anthropomorphism and diversity in virtual humans: Their influence on the trust and attitudes of Gen Z consumers. Corporate Communications: An International Journal, 30(5), 888–914.</a:t>
+            </a:r>
+            <a:endParaRPr lang="en-US" sz="1300" dirty="0"/>
+          </a:p>
+          <a:p>
+            <a:pPr indent="0" marL="0">
+              <a:spcAft>
+                <a:spcPts val="600"/>
+              </a:spcAft>
+              <a:buNone/>
+            </a:pPr>
+            <a:r>
+              <a:rPr lang="en-US" sz="1300" b="1" dirty="0">
+                <a:solidFill>
+                  <a:schemeClr val="accent4"/>
+                </a:solidFill>
+              </a:rPr>
+              <a:t>38. </a:t>
+            </a:r>
+            <a:r>
+              <a:rPr lang="en-US" sz="1300" dirty="0">
+                <a:solidFill>
+                  <a:schemeClr val="tx1"/>
+                </a:solidFill>
+              </a:rPr>
+              <a:t>Lou, C., &amp; Yuan, S. (2019). Influencer marketing: How message value and credibility affect consumer trust of branded content on social media. Journal of Interactive Advertising, 19(1), 58–73.</a:t>
+            </a:r>
+            <a:endParaRPr lang="en-US" sz="1300" dirty="0"/>
+          </a:p>
+          <a:p>
+            <a:pPr indent="0" marL="0">
+              <a:spcAft>
+                <a:spcPts val="600"/>
+              </a:spcAft>
+              <a:buNone/>
+            </a:pPr>
+            <a:r>
+              <a:rPr lang="en-US" sz="1300" b="1" dirty="0">
+                <a:solidFill>
+                  <a:schemeClr val="accent4"/>
+                </a:solidFill>
+              </a:rPr>
+              <a:t>39. </a:t>
+            </a:r>
+            <a:r>
+              <a:rPr lang="en-US" sz="1300" dirty="0">
+                <a:solidFill>
+                  <a:schemeClr val="tx1"/>
+                </a:solidFill>
+              </a:rPr>
+              <a:t>Lou, C., Kiew, S. T. J., Chen, T., Lee, T. Y. M., Ong, J. E. C., &amp; Phua, Z. (2023). Authentically fake? How consumers respond to the influence of virtual influencers. Journal of Advertising, 52(4), 540–557.</a:t>
+            </a:r>
+            <a:endParaRPr lang="en-US" sz="1300" dirty="0"/>
+          </a:p>
+          <a:p>
+            <a:pPr indent="0" marL="0">
+              <a:spcAft>
+                <a:spcPts val="600"/>
+              </a:spcAft>
+              <a:buNone/>
+            </a:pPr>
+            <a:r>
+              <a:rPr lang="en-US" sz="1300" b="1" dirty="0">
+                <a:solidFill>
+                  <a:schemeClr val="accent4"/>
+                </a:solidFill>
+              </a:rPr>
+              <a:t>40. </a:t>
+            </a:r>
+            <a:r>
+              <a:rPr lang="en-US" sz="1300" dirty="0">
+                <a:solidFill>
+                  <a:schemeClr val="tx1"/>
+                </a:solidFill>
+              </a:rPr>
+              <a:t>Masuda, H., Han, S. H., &amp; Lee, J. (2022). Impacts of influencer attributes on purchase intentions in social media influencer marketing: Mediating roles of characterizations. Technological Forecasting and Social Change, 174, Article 121246.</a:t>
+            </a:r>
+            <a:endParaRPr lang="en-US" sz="1300" dirty="0"/>
+          </a:p>
+          <a:p>
+            <a:pPr indent="0" marL="0">
+              <a:spcAft>
+                <a:spcPts val="600"/>
+              </a:spcAft>
+              <a:buNone/>
+            </a:pPr>
+            <a:r>
+              <a:rPr lang="en-US" sz="1300" b="1" dirty="0">
+                <a:solidFill>
+                  <a:schemeClr val="accent4"/>
+                </a:solidFill>
+              </a:rPr>
+              <a:t>41. </a:t>
+            </a:r>
+            <a:r>
+              <a:rPr lang="en-US" sz="1300" dirty="0">
+                <a:solidFill>
+                  <a:schemeClr val="tx1"/>
+                </a:solidFill>
+              </a:rPr>
+              <a:t>Mayer, R. C., Davis, J. H., &amp; Schoorman, F. D. (1995). An integrative model of organizational trust. Academy of Management Review, 20(3), 709–734.</a:t>
+            </a:r>
+            <a:endParaRPr lang="en-US" sz="1300" dirty="0"/>
+          </a:p>
+          <a:p>
+            <a:pPr indent="0" marL="0">
+              <a:spcAft>
+                <a:spcPts val="600"/>
+              </a:spcAft>
+              <a:buNone/>
+            </a:pPr>
+            <a:r>
+              <a:rPr lang="en-US" sz="1300" b="1" dirty="0">
+                <a:solidFill>
+                  <a:schemeClr val="accent4"/>
+                </a:solidFill>
+              </a:rPr>
+              <a:t>42. </a:t>
+            </a:r>
+            <a:r>
+              <a:rPr lang="en-US" sz="1300" dirty="0">
+                <a:solidFill>
+                  <a:schemeClr val="tx1"/>
+                </a:solidFill>
+              </a:rPr>
+              <a:t>McCroskey, J. C., Richmond, V. P., &amp; Daly, J. A. (1975). The development of a measure of perceived homophily in interpersonal communication. Human Communication Research, 1(4), 323–332.</a:t>
+            </a:r>
+            <a:endParaRPr lang="en-US" sz="1300" dirty="0"/>
+          </a:p>
+        </p:txBody>
+      </p:sp>
+      <p:sp>
+        <p:nvSpPr>
+          <p:cNvPr id="4" name="Text 2"/>
+          <p:cNvSpPr txBox="1"/>
+          <p:nvPr/>
+        </p:nvSpPr>
+        <p:spPr>
+          <a:xfrm>
+            <a:off x="6227064" y="1645920"/>
+            <a:ext cx="5413248" cy="4754880"/>
+          </a:xfrm>
+          <a:prstGeom prst="rect">
+            <a:avLst/>
+          </a:prstGeom>
+          <a:noFill/>
+          <a:ln/>
+        </p:spPr>
+        <p:txBody>
+          <a:bodyPr wrap="square" lIns="0" tIns="0" rIns="0" bIns="0" rtlCol="0" anchor="t"/>
+          <a:lstStyle/>
+          <a:p>
+            <a:pPr indent="0" marL="0">
+              <a:spcAft>
+                <a:spcPts val="600"/>
+              </a:spcAft>
+              <a:buNone/>
+            </a:pPr>
+            <a:r>
+              <a:rPr lang="en-US" sz="1300" b="1" dirty="0">
+                <a:solidFill>
+                  <a:schemeClr val="accent4"/>
+                </a:solidFill>
+              </a:rPr>
+              <a:t>43. </a:t>
+            </a:r>
+            <a:r>
+              <a:rPr lang="en-US" sz="1300" dirty="0">
+                <a:solidFill>
+                  <a:schemeClr val="tx1"/>
+                </a:solidFill>
+              </a:rPr>
+              <a:t>McPherson, M., Smith-Lovin, L., &amp; Cook, J. M. (2001). Birds of a feather: Homophily in social networks. Annual Review of Sociology, 27, 415–444.</a:t>
+            </a:r>
+            <a:endParaRPr lang="en-US" sz="1300" dirty="0"/>
+          </a:p>
+          <a:p>
+            <a:pPr indent="0" marL="0">
+              <a:spcAft>
+                <a:spcPts val="600"/>
+              </a:spcAft>
+              <a:buNone/>
+            </a:pPr>
+            <a:r>
+              <a:rPr lang="en-US" sz="1300" b="1" dirty="0">
+                <a:solidFill>
+                  <a:schemeClr val="accent4"/>
+                </a:solidFill>
+              </a:rPr>
+              <a:t>44. </a:t>
+            </a:r>
+            <a:r>
+              <a:rPr lang="en-US" sz="1300" dirty="0">
+                <a:solidFill>
+                  <a:schemeClr val="tx1"/>
+                </a:solidFill>
+              </a:rPr>
+              <a:t>Mehrabian, A., &amp; Russell, J. A. (1974). An approach to environmental psychology. MIT Press.</a:t>
+            </a:r>
+            <a:endParaRPr lang="en-US" sz="1300" dirty="0"/>
+          </a:p>
+          <a:p>
+            <a:pPr indent="0" marL="0">
+              <a:spcAft>
+                <a:spcPts val="600"/>
+              </a:spcAft>
+              <a:buNone/>
+            </a:pPr>
+            <a:r>
+              <a:rPr lang="en-US" sz="1300" b="1" dirty="0">
+                <a:solidFill>
+                  <a:schemeClr val="accent4"/>
+                </a:solidFill>
+              </a:rPr>
+              <a:t>45. </a:t>
+            </a:r>
+            <a:r>
+              <a:rPr lang="en-US" sz="1300" dirty="0">
+                <a:solidFill>
+                  <a:schemeClr val="tx1"/>
+                </a:solidFill>
+              </a:rPr>
+              <a:t>Miao, F., Kozlenkova, I. V., Wang, H., Xie, T., &amp; Palmatier, R. W. (2022). An emerging theory of avatar marketing. Journal of Marketing, 86(1), 67–90.</a:t>
+            </a:r>
+            <a:endParaRPr lang="en-US" sz="1300" dirty="0"/>
+          </a:p>
+          <a:p>
+            <a:pPr indent="0" marL="0">
+              <a:spcAft>
+                <a:spcPts val="600"/>
+              </a:spcAft>
+              <a:buNone/>
+            </a:pPr>
+            <a:r>
+              <a:rPr lang="en-US" sz="1300" b="1" dirty="0">
+                <a:solidFill>
+                  <a:schemeClr val="accent4"/>
+                </a:solidFill>
+              </a:rPr>
+              <a:t>46. </a:t>
+            </a:r>
+            <a:r>
+              <a:rPr lang="en-US" sz="1300" dirty="0">
+                <a:solidFill>
+                  <a:schemeClr val="tx1"/>
+                </a:solidFill>
+              </a:rPr>
+              <a:t>Morgan, R. M., &amp; Hunt, S. D. (1994). The commitment-trust theory of relationship marketing. Journal of Marketing, 58(3), 20–38.</a:t>
+            </a:r>
+            <a:endParaRPr lang="en-US" sz="1300" dirty="0"/>
+          </a:p>
+          <a:p>
+            <a:pPr indent="0" marL="0">
+              <a:spcAft>
+                <a:spcPts val="600"/>
+              </a:spcAft>
+              <a:buNone/>
+            </a:pPr>
+            <a:r>
+              <a:rPr lang="en-US" sz="1300" b="1" dirty="0">
+                <a:solidFill>
+                  <a:schemeClr val="accent4"/>
+                </a:solidFill>
+              </a:rPr>
+              <a:t>47. </a:t>
+            </a:r>
+            <a:r>
+              <a:rPr lang="en-US" sz="1300" dirty="0">
+                <a:solidFill>
+                  <a:schemeClr val="tx1"/>
+                </a:solidFill>
+              </a:rPr>
+              <a:t>Mori, M., MacDorman, K. F., &amp; Kageki, N. (2012). The uncanny valley [From the field]. IEEE Robotics &amp; Automation Magazine, 19(2), 98–100.</a:t>
+            </a:r>
+            <a:endParaRPr lang="en-US" sz="1300" dirty="0"/>
+          </a:p>
+          <a:p>
+            <a:pPr indent="0" marL="0">
+              <a:spcAft>
+                <a:spcPts val="600"/>
+              </a:spcAft>
+              <a:buNone/>
+            </a:pPr>
+            <a:r>
+              <a:rPr lang="en-US" sz="1300" b="1" dirty="0">
+                <a:solidFill>
+                  <a:schemeClr val="accent4"/>
+                </a:solidFill>
+              </a:rPr>
+              <a:t>48. </a:t>
+            </a:r>
+            <a:r>
+              <a:rPr lang="en-US" sz="1300" dirty="0">
+                <a:solidFill>
+                  <a:schemeClr val="tx1"/>
+                </a:solidFill>
+              </a:rPr>
+              <a:t>Moulard, J. G., Garrity, C. P., &amp; Rice, D. H. (2015). What makes a human brand authentic? Identifying the antecedents of celebrity authenticity. Psychology &amp; Marketing, 32(2), 173–186.</a:t>
+            </a:r>
+            <a:endParaRPr lang="en-US" sz="1300" dirty="0"/>
+          </a:p>
+        </p:txBody>
+      </p:sp>
+      <p:sp>
+        <p:nvSpPr>
+          <p:cNvPr id="25" name="Slide Number Placeholder 0"/>
+          <p:cNvSpPr>
+            <a:spLocks noGrp="1"/>
+          </p:cNvSpPr>
+          <p:nvPr>
+            <p:ph type="sldNum" sz="quarter" idx="4294967295"/>
+          </p:nvPr>
+        </p:nvSpPr>
+        <p:spPr>
+          <a:xfrm>
+            <a:off x="11155680" y="6400800"/>
+            <a:ext cx="548640" cy="274320"/>
+          </a:xfrm>
+          <a:prstGeom prst="rect">
+            <a:avLst/>
+          </a:prstGeom>
+          <a:extLst>
+            <a:ext uri="{C572A759-6A51-4108-AA02-DFA0A04FC94B}">
+              <ma14:wrappingTextBoxFlag xmlns:ma14="http://schemas.microsoft.com/office/mac/drawingml/2011/main" val="0"/>
+            </a:ext>
+          </a:extLst>
+        </p:spPr>
+        <p:txBody>
+          <a:bodyPr/>
+          <a:lstStyle>
+            <a:lvl1pPr>
+              <a:defRPr sz="1200">
+                <a:solidFill>
+                  <a:schemeClr val="accent3"/>
+                </a:solidFill>
+              </a:defRPr>
+            </a:lvl1pPr>
+          </a:lstStyle>
+          <a:p>
+            <a:pPr algn="r"/>
+            <a:fld id="{F7021451-1387-4CA6-816F-3879F97B5CBC}" type="slidenum">
+              <a:rPr b="0" lang="en-US"/>
+              <a:t>22</a:t>
+            </a:fld>
+            <a:endParaRPr lang="en-US"/>
+          </a:p>
+        </p:txBody>
+      </p:sp>
+    </p:spTree>
+  </p:cSld>
+  <p:clrMapOvr>
+    <a:masterClrMapping/>
+  </p:clrMapOvr>
+</p:sld>
+</file>
+
+<file path=ppt/slides/slide23.xml><?xml version="1.0" encoding="utf-8"?>
+<p:sld xmlns:a="http://schemas.openxmlformats.org/drawingml/2006/main" xmlns:r="http://schemas.openxmlformats.org/officeDocument/2006/relationships" xmlns:p="http://schemas.openxmlformats.org/presentationml/2006/main">
+  <p:cSld name="Slide 23">
+    <p:spTree>
+      <p:nvGrpSpPr>
+        <p:cNvPr id="1" name=""/>
+        <p:cNvGrpSpPr/>
+        <p:nvPr/>
+      </p:nvGrpSpPr>
+      <p:grpSpPr>
+        <a:xfrm>
+          <a:off x="0" y="0"/>
+          <a:ext cx="0" cy="0"/>
+          <a:chOff x="0" y="0"/>
+          <a:chExt cx="0" cy="0"/>
+        </a:xfrm>
+      </p:grpSpPr>
+      <p:sp>
+        <p:nvSpPr>
+          <p:cNvPr id="2" name="Text 3"/>
+          <p:cNvSpPr/>
+          <p:nvPr>
+            <p:ph idx="103" type="title" hasCustomPrompt="1"/>
+          </p:nvPr>
+        </p:nvSpPr>
+        <p:spPr>
+          <a:xfrm>
+            <a:off x="548640" y="749808"/>
+            <a:ext cx="11091672" cy="731520"/>
+          </a:xfrm>
+          <a:prstGeom prst="rect">
+            <a:avLst/>
+          </a:prstGeom>
+          <a:noFill/>
+          <a:ln/>
+        </p:spPr>
+        <p:txBody>
+          <a:bodyPr wrap="square" lIns="0" tIns="0" rIns="0" bIns="0" rtlCol="0" anchor="ctr"/>
+          <a:lstStyle/>
+          <a:p>
+            <a:pPr algn="l" indent="0" marL="0">
+              <a:buNone/>
+            </a:pPr>
+            <a:r>
+              <a:rPr lang="en-US" sz="2800" b="1" dirty="0">
+                <a:solidFill>
+                  <a:schemeClr val="tx1"/>
+                </a:solidFill>
+              </a:rPr>
+              <a:t>REFERENCES (CONTD.)</a:t>
+            </a:r>
+            <a:endParaRPr lang="en-US" sz="2800" dirty="0"/>
+          </a:p>
+        </p:txBody>
+      </p:sp>
+      <p:sp>
+        <p:nvSpPr>
+          <p:cNvPr id="3" name="Text 1"/>
+          <p:cNvSpPr txBox="1"/>
+          <p:nvPr/>
+        </p:nvSpPr>
+        <p:spPr>
+          <a:xfrm>
+            <a:off x="548640" y="1645920"/>
+            <a:ext cx="5413248" cy="4754880"/>
+          </a:xfrm>
+          <a:prstGeom prst="rect">
+            <a:avLst/>
+          </a:prstGeom>
+          <a:noFill/>
+          <a:ln/>
+        </p:spPr>
+        <p:txBody>
+          <a:bodyPr wrap="square" lIns="0" tIns="0" rIns="0" bIns="0" rtlCol="0" anchor="t"/>
+          <a:lstStyle/>
+          <a:p>
+            <a:pPr indent="0" marL="0">
+              <a:spcAft>
+                <a:spcPts val="600"/>
+              </a:spcAft>
+              <a:buNone/>
+            </a:pPr>
+            <a:r>
+              <a:rPr lang="en-US" sz="1300" b="1" dirty="0">
+                <a:solidFill>
+                  <a:schemeClr val="accent4"/>
+                </a:solidFill>
+              </a:rPr>
+              <a:t>49. </a:t>
+            </a:r>
+            <a:r>
+              <a:rPr lang="en-US" sz="1300" dirty="0">
+                <a:solidFill>
+                  <a:schemeClr val="tx1"/>
+                </a:solidFill>
+              </a:rPr>
+              <a:t>Mouritzen, S. L. T., Penttinen, V., &amp; Pedersen, S. (2024). Virtual influencer marketing: The good, the bad and the unreal. European Journal of Marketing, 58(2).</a:t>
+            </a:r>
+            <a:endParaRPr lang="en-US" sz="1300" dirty="0"/>
+          </a:p>
+          <a:p>
+            <a:pPr indent="0" marL="0">
+              <a:spcAft>
+                <a:spcPts val="600"/>
+              </a:spcAft>
+              <a:buNone/>
+            </a:pPr>
+            <a:r>
+              <a:rPr lang="en-US" sz="1300" b="1" dirty="0">
+                <a:solidFill>
+                  <a:schemeClr val="accent4"/>
+                </a:solidFill>
+              </a:rPr>
+              <a:t>50. </a:t>
+            </a:r>
+            <a:r>
+              <a:rPr lang="en-US" sz="1300" dirty="0">
+                <a:solidFill>
+                  <a:schemeClr val="tx1"/>
+                </a:solidFill>
+              </a:rPr>
+              <a:t>Ohanian, R. (1990). Construction and validation of a scale to measure celebrity endorsers' perceived expertise, trustworthiness, and attractiveness. Journal of Advertising, 19(3), 39–52.</a:t>
+            </a:r>
+            <a:endParaRPr lang="en-US" sz="1300" dirty="0"/>
+          </a:p>
+          <a:p>
+            <a:pPr indent="0" marL="0">
+              <a:spcAft>
+                <a:spcPts val="600"/>
+              </a:spcAft>
+              <a:buNone/>
+            </a:pPr>
+            <a:r>
+              <a:rPr lang="en-US" sz="1300" b="1" dirty="0">
+                <a:solidFill>
+                  <a:schemeClr val="accent4"/>
+                </a:solidFill>
+              </a:rPr>
+              <a:t>51. </a:t>
+            </a:r>
+            <a:r>
+              <a:rPr lang="en-US" sz="1300" dirty="0">
+                <a:solidFill>
+                  <a:schemeClr val="tx1"/>
+                </a:solidFill>
+              </a:rPr>
+              <a:t>Pan, M., Blut, M., Ghiassaleh, A., &amp; Lee, Z. W. Y. (2025). Influencer marketing effectiveness: A meta-analytic review. Journal of the Academy of Marketing Science, 53(1), 52–78.</a:t>
+            </a:r>
+            <a:endParaRPr lang="en-US" sz="1300" dirty="0"/>
+          </a:p>
+          <a:p>
+            <a:pPr indent="0" marL="0">
+              <a:spcAft>
+                <a:spcPts val="600"/>
+              </a:spcAft>
+              <a:buNone/>
+            </a:pPr>
+            <a:r>
+              <a:rPr lang="en-US" sz="1300" b="1" dirty="0">
+                <a:solidFill>
+                  <a:schemeClr val="accent4"/>
+                </a:solidFill>
+              </a:rPr>
+              <a:t>52. </a:t>
+            </a:r>
+            <a:r>
+              <a:rPr lang="en-US" sz="1300" dirty="0">
+                <a:solidFill>
+                  <a:schemeClr val="tx1"/>
+                </a:solidFill>
+              </a:rPr>
+              <a:t>Pöyry, E., Pelkonen, M., Naumanen, E., &amp; Laaksonen, S.-M. (2019). A call for authenticity: Audience responses to social media influencer endorsements in strategic communication. International Journal of Strategic Communication, 13(4), 336–351.</a:t>
+            </a:r>
+            <a:endParaRPr lang="en-US" sz="1300" dirty="0"/>
+          </a:p>
+          <a:p>
+            <a:pPr indent="0" marL="0">
+              <a:spcAft>
+                <a:spcPts val="600"/>
+              </a:spcAft>
+              <a:buNone/>
+            </a:pPr>
+            <a:r>
+              <a:rPr lang="en-US" sz="1300" b="1" dirty="0">
+                <a:solidFill>
+                  <a:schemeClr val="accent4"/>
+                </a:solidFill>
+              </a:rPr>
+              <a:t>53. </a:t>
+            </a:r>
+            <a:r>
+              <a:rPr lang="en-US" sz="1300" dirty="0">
+                <a:solidFill>
+                  <a:schemeClr val="tx1"/>
+                </a:solidFill>
+              </a:rPr>
+              <a:t>Reeves, B., &amp; Nass, C. (1996). The media equation: How people treat computers, television, and new media like real people and places. Cambridge University Press.</a:t>
+            </a:r>
+            <a:endParaRPr lang="en-US" sz="1300" dirty="0"/>
+          </a:p>
+          <a:p>
+            <a:pPr indent="0" marL="0">
+              <a:spcAft>
+                <a:spcPts val="600"/>
+              </a:spcAft>
+              <a:buNone/>
+            </a:pPr>
+            <a:r>
+              <a:rPr lang="en-US" sz="1300" b="1" dirty="0">
+                <a:solidFill>
+                  <a:schemeClr val="accent4"/>
+                </a:solidFill>
+              </a:rPr>
+              <a:t>54. </a:t>
+            </a:r>
+            <a:r>
+              <a:rPr lang="en-US" sz="1300" dirty="0">
+                <a:solidFill>
+                  <a:schemeClr val="tx1"/>
+                </a:solidFill>
+              </a:rPr>
+              <a:t>Saima, &amp; Khan, M. A. (2021). Effect of social media influencer marketing on consumers' purchase intention and the mediating role of credibility. Journal of Promotion Management, 27(4), 503–523.</a:t>
+            </a:r>
+            <a:endParaRPr lang="en-US" sz="1300" dirty="0"/>
+          </a:p>
+        </p:txBody>
+      </p:sp>
+      <p:sp>
+        <p:nvSpPr>
+          <p:cNvPr id="4" name="Text 2"/>
+          <p:cNvSpPr txBox="1"/>
+          <p:nvPr/>
+        </p:nvSpPr>
+        <p:spPr>
+          <a:xfrm>
+            <a:off x="6227064" y="1645920"/>
+            <a:ext cx="5413248" cy="4754880"/>
+          </a:xfrm>
+          <a:prstGeom prst="rect">
+            <a:avLst/>
+          </a:prstGeom>
+          <a:noFill/>
+          <a:ln/>
+        </p:spPr>
+        <p:txBody>
+          <a:bodyPr wrap="square" lIns="0" tIns="0" rIns="0" bIns="0" rtlCol="0" anchor="t"/>
+          <a:lstStyle/>
+          <a:p>
+            <a:pPr indent="0" marL="0">
+              <a:spcAft>
+                <a:spcPts val="600"/>
+              </a:spcAft>
+              <a:buNone/>
+            </a:pPr>
+            <a:r>
+              <a:rPr lang="en-US" sz="1300" b="1" dirty="0">
+                <a:solidFill>
+                  <a:schemeClr val="accent4"/>
+                </a:solidFill>
+              </a:rPr>
+              <a:t>55. </a:t>
+            </a:r>
+            <a:r>
+              <a:rPr lang="en-US" sz="1300" dirty="0">
+                <a:solidFill>
+                  <a:schemeClr val="tx1"/>
+                </a:solidFill>
+              </a:rPr>
+              <a:t>Sands, S., Campbell, C. L., Plangger, K., &amp; Ferraro, C. (2022). Unreal influence: Leveraging AI in influencer marketing. European Journal of Marketing, 56(6), 1721–1747.</a:t>
+            </a:r>
+            <a:endParaRPr lang="en-US" sz="1300" dirty="0"/>
+          </a:p>
+          <a:p>
+            <a:pPr indent="0" marL="0">
+              <a:spcAft>
+                <a:spcPts val="600"/>
+              </a:spcAft>
+              <a:buNone/>
+            </a:pPr>
+            <a:r>
+              <a:rPr lang="en-US" sz="1300" b="1" dirty="0">
+                <a:solidFill>
+                  <a:schemeClr val="accent4"/>
+                </a:solidFill>
+              </a:rPr>
+              <a:t>56. </a:t>
+            </a:r>
+            <a:r>
+              <a:rPr lang="en-US" sz="1300" dirty="0">
+                <a:solidFill>
+                  <a:schemeClr val="tx1"/>
+                </a:solidFill>
+              </a:rPr>
+              <a:t>Schouten, A. P., Janssen, L., &amp; Verspaget, M. (2020). Celebrity vs. influencer endorsements in advertising: The role of identification, credibility, and product-endorser fit. International Journal of Advertising, 39(2), 258–281.</a:t>
+            </a:r>
+            <a:endParaRPr lang="en-US" sz="1300" dirty="0"/>
+          </a:p>
+          <a:p>
+            <a:pPr indent="0" marL="0">
+              <a:spcAft>
+                <a:spcPts val="600"/>
+              </a:spcAft>
+              <a:buNone/>
+            </a:pPr>
+            <a:r>
+              <a:rPr lang="en-US" sz="1300" b="1" dirty="0">
+                <a:solidFill>
+                  <a:schemeClr val="accent4"/>
+                </a:solidFill>
+              </a:rPr>
+              <a:t>57. </a:t>
+            </a:r>
+            <a:r>
+              <a:rPr lang="en-US" sz="1300" dirty="0">
+                <a:solidFill>
+                  <a:schemeClr val="tx1"/>
+                </a:solidFill>
+              </a:rPr>
+              <a:t>Sokolova, K., &amp; Kefi, H. (2020). Instagram and YouTube bloggers promote it, why should I buy? How credibility and parasocial interaction influence purchase intentions. Journal of Retailing and Consumer Services, 53, Article 101742.</a:t>
+            </a:r>
+            <a:endParaRPr lang="en-US" sz="1300" dirty="0"/>
+          </a:p>
+          <a:p>
+            <a:pPr indent="0" marL="0">
+              <a:spcAft>
+                <a:spcPts val="600"/>
+              </a:spcAft>
+              <a:buNone/>
+            </a:pPr>
+            <a:r>
+              <a:rPr lang="en-US" sz="1300" b="1" dirty="0">
+                <a:solidFill>
+                  <a:schemeClr val="accent4"/>
+                </a:solidFill>
+              </a:rPr>
+              <a:t>58. </a:t>
+            </a:r>
+            <a:r>
+              <a:rPr lang="en-US" sz="1300" dirty="0">
+                <a:solidFill>
+                  <a:schemeClr val="tx1"/>
+                </a:solidFill>
+              </a:rPr>
+              <a:t>Spears, N., &amp; Singh, S. N. (2004). Measuring attitude toward the brand and purchase intentions. Journal of Current Issues &amp; Research in Advertising, 26(2), 53–66.</a:t>
+            </a:r>
+            <a:endParaRPr lang="en-US" sz="1300" dirty="0"/>
+          </a:p>
+          <a:p>
+            <a:pPr indent="0" marL="0">
+              <a:spcAft>
+                <a:spcPts val="600"/>
+              </a:spcAft>
+              <a:buNone/>
+            </a:pPr>
+            <a:r>
+              <a:rPr lang="en-US" sz="1300" b="1" dirty="0">
+                <a:solidFill>
+                  <a:schemeClr val="accent4"/>
+                </a:solidFill>
+              </a:rPr>
+              <a:t>59. </a:t>
+            </a:r>
+            <a:r>
+              <a:rPr lang="en-US" sz="1300" dirty="0">
+                <a:solidFill>
+                  <a:schemeClr val="tx1"/>
+                </a:solidFill>
+              </a:rPr>
+              <a:t>Stein, J.-P., Breves, P. L., &amp; Anders, N. (2024). Parasocial interactions with real and virtual influencers: The role of perceived similarity and human-likeness. New Media &amp; Society, 26(6), 3433–3453.</a:t>
+            </a:r>
+            <a:endParaRPr lang="en-US" sz="1300" dirty="0"/>
+          </a:p>
+          <a:p>
+            <a:pPr indent="0" marL="0">
+              <a:spcAft>
+                <a:spcPts val="600"/>
+              </a:spcAft>
+              <a:buNone/>
+            </a:pPr>
+            <a:r>
+              <a:rPr lang="en-US" sz="1300" b="1" dirty="0">
+                <a:solidFill>
+                  <a:schemeClr val="accent4"/>
+                </a:solidFill>
+              </a:rPr>
+              <a:t>60. </a:t>
+            </a:r>
+            <a:r>
+              <a:rPr lang="en-US" sz="1300" dirty="0">
+                <a:solidFill>
+                  <a:schemeClr val="tx1"/>
+                </a:solidFill>
+              </a:rPr>
+              <a:t>Trivedi, J., &amp; Sama, R. (2020). The effect of influencer marketing on consumers' brand admiration and online purchase intentions: An emerging market perspective. Journal of Internet Commerce, 19(1), 103–124.</a:t>
+            </a:r>
+            <a:endParaRPr lang="en-US" sz="1300" dirty="0"/>
+          </a:p>
+        </p:txBody>
+      </p:sp>
+      <p:sp>
+        <p:nvSpPr>
+          <p:cNvPr id="25" name="Slide Number Placeholder 0"/>
+          <p:cNvSpPr>
+            <a:spLocks noGrp="1"/>
+          </p:cNvSpPr>
+          <p:nvPr>
+            <p:ph type="sldNum" sz="quarter" idx="4294967295"/>
+          </p:nvPr>
+        </p:nvSpPr>
+        <p:spPr>
+          <a:xfrm>
+            <a:off x="11155680" y="6400800"/>
+            <a:ext cx="548640" cy="274320"/>
+          </a:xfrm>
+          <a:prstGeom prst="rect">
+            <a:avLst/>
+          </a:prstGeom>
+          <a:extLst>
+            <a:ext uri="{C572A759-6A51-4108-AA02-DFA0A04FC94B}">
+              <ma14:wrappingTextBoxFlag xmlns:ma14="http://schemas.microsoft.com/office/mac/drawingml/2011/main" val="0"/>
+            </a:ext>
+          </a:extLst>
+        </p:spPr>
+        <p:txBody>
+          <a:bodyPr/>
+          <a:lstStyle>
+            <a:lvl1pPr>
+              <a:defRPr sz="1200">
+                <a:solidFill>
+                  <a:schemeClr val="accent3"/>
+                </a:solidFill>
+              </a:defRPr>
+            </a:lvl1pPr>
+          </a:lstStyle>
+          <a:p>
+            <a:pPr algn="r"/>
+            <a:fld id="{F7021451-1387-4CA6-816F-3879F97B5CBC}" type="slidenum">
+              <a:rPr b="0" lang="en-US"/>
+              <a:t>23</a:t>
+            </a:fld>
+            <a:endParaRPr lang="en-US"/>
+          </a:p>
+        </p:txBody>
+      </p:sp>
+    </p:spTree>
+  </p:cSld>
+  <p:clrMapOvr>
+    <a:masterClrMapping/>
+  </p:clrMapOvr>
+</p:sld>
+</file>
+
+<file path=ppt/slides/slide24.xml><?xml version="1.0" encoding="utf-8"?>
+<p:sld xmlns:a="http://schemas.openxmlformats.org/drawingml/2006/main" xmlns:r="http://schemas.openxmlformats.org/officeDocument/2006/relationships" xmlns:p="http://schemas.openxmlformats.org/presentationml/2006/main">
+  <p:cSld name="Slide 24">
+    <p:spTree>
+      <p:nvGrpSpPr>
+        <p:cNvPr id="1" name=""/>
+        <p:cNvGrpSpPr/>
+        <p:nvPr/>
+      </p:nvGrpSpPr>
+      <p:grpSpPr>
+        <a:xfrm>
+          <a:off x="0" y="0"/>
+          <a:ext cx="0" cy="0"/>
+          <a:chOff x="0" y="0"/>
+          <a:chExt cx="0" cy="0"/>
+        </a:xfrm>
+      </p:grpSpPr>
+      <p:sp>
+        <p:nvSpPr>
+          <p:cNvPr id="2" name="Text 3"/>
+          <p:cNvSpPr/>
+          <p:nvPr>
+            <p:ph idx="103" type="title" hasCustomPrompt="1"/>
+          </p:nvPr>
+        </p:nvSpPr>
+        <p:spPr>
+          <a:xfrm>
+            <a:off x="548640" y="749808"/>
+            <a:ext cx="11091672" cy="731520"/>
+          </a:xfrm>
+          <a:prstGeom prst="rect">
+            <a:avLst/>
+          </a:prstGeom>
+          <a:noFill/>
+          <a:ln/>
+        </p:spPr>
+        <p:txBody>
+          <a:bodyPr wrap="square" lIns="0" tIns="0" rIns="0" bIns="0" rtlCol="0" anchor="ctr"/>
+          <a:lstStyle/>
+          <a:p>
+            <a:pPr algn="l" indent="0" marL="0">
+              <a:buNone/>
+            </a:pPr>
+            <a:r>
+              <a:rPr lang="en-US" sz="2800" b="1" dirty="0">
+                <a:solidFill>
+                  <a:schemeClr val="tx1"/>
+                </a:solidFill>
+              </a:rPr>
+              <a:t>REFERENCES (CONTD.)</a:t>
+            </a:r>
+            <a:endParaRPr lang="en-US" sz="2800" dirty="0"/>
+          </a:p>
+        </p:txBody>
+      </p:sp>
+      <p:sp>
+        <p:nvSpPr>
+          <p:cNvPr id="3" name="Text 1"/>
+          <p:cNvSpPr txBox="1"/>
+          <p:nvPr/>
+        </p:nvSpPr>
+        <p:spPr>
+          <a:xfrm>
+            <a:off x="548640" y="1645920"/>
+            <a:ext cx="5413248" cy="4754880"/>
+          </a:xfrm>
+          <a:prstGeom prst="rect">
+            <a:avLst/>
+          </a:prstGeom>
+          <a:noFill/>
+          <a:ln/>
+        </p:spPr>
+        <p:txBody>
+          <a:bodyPr wrap="square" lIns="0" tIns="0" rIns="0" bIns="0" rtlCol="0" anchor="t"/>
+          <a:lstStyle/>
+          <a:p>
+            <a:pPr indent="0" marL="0">
+              <a:spcAft>
+                <a:spcPts val="600"/>
+              </a:spcAft>
+              <a:buNone/>
+            </a:pPr>
+            <a:r>
+              <a:rPr lang="en-US" sz="1300" b="1" dirty="0">
+                <a:solidFill>
+                  <a:schemeClr val="accent4"/>
+                </a:solidFill>
+              </a:rPr>
+              <a:t>61. </a:t>
+            </a:r>
+            <a:r>
+              <a:rPr lang="en-US" sz="1300" dirty="0">
+                <a:solidFill>
+                  <a:schemeClr val="tx1"/>
+                </a:solidFill>
+              </a:rPr>
+              <a:t>Volles, B. K., Park, J., Van Kerckhove, A., &amp; Geuens, M. (2024). How and when do virtual influencers positively affect consumer responses to endorsed brands? Journal of Business Research, 183, Article 114863.</a:t>
+            </a:r>
+            <a:endParaRPr lang="en-US" sz="1300" dirty="0"/>
+          </a:p>
+          <a:p>
+            <a:pPr indent="0" marL="0">
+              <a:spcAft>
+                <a:spcPts val="600"/>
+              </a:spcAft>
+              <a:buNone/>
+            </a:pPr>
+            <a:r>
+              <a:rPr lang="en-US" sz="1300" b="1" dirty="0">
+                <a:solidFill>
+                  <a:schemeClr val="accent4"/>
+                </a:solidFill>
+              </a:rPr>
+              <a:t>62. </a:t>
+            </a:r>
+            <a:r>
+              <a:rPr lang="en-US" sz="1300" dirty="0">
+                <a:solidFill>
+                  <a:schemeClr val="tx1"/>
+                </a:solidFill>
+              </a:rPr>
+              <a:t>Vrontis, D., Makrides, A., Christofi, M., &amp; Thrassou, A. (2021). Social media influencer marketing: A systematic review, integrative framework and future research agenda. International Journal of Consumer Studies, 45(4), 617–644.</a:t>
+            </a:r>
+            <a:endParaRPr lang="en-US" sz="1300" dirty="0"/>
+          </a:p>
+          <a:p>
+            <a:pPr indent="0" marL="0">
+              <a:spcAft>
+                <a:spcPts val="600"/>
+              </a:spcAft>
+              <a:buNone/>
+            </a:pPr>
+            <a:r>
+              <a:rPr lang="en-US" sz="1300" b="1" dirty="0">
+                <a:solidFill>
+                  <a:schemeClr val="accent4"/>
+                </a:solidFill>
+              </a:rPr>
+              <a:t>63. </a:t>
+            </a:r>
+            <a:r>
+              <a:rPr lang="en-US" sz="1300" dirty="0">
+                <a:solidFill>
+                  <a:schemeClr val="tx1"/>
+                </a:solidFill>
+              </a:rPr>
+              <a:t>Waytz, A., Heafner, J., &amp; Epley, N. (2014). The mind in the machine: Anthropomorphism increases trust in an autonomous vehicle. Journal of Experimental Social Psychology, 52, 113–117.</a:t>
+            </a:r>
+            <a:endParaRPr lang="en-US" sz="1300" dirty="0"/>
+          </a:p>
+          <a:p>
+            <a:pPr indent="0" marL="0">
+              <a:spcAft>
+                <a:spcPts val="600"/>
+              </a:spcAft>
+              <a:buNone/>
+            </a:pPr>
+            <a:r>
+              <a:rPr lang="en-US" sz="1300" b="1" dirty="0">
+                <a:solidFill>
+                  <a:schemeClr val="accent4"/>
+                </a:solidFill>
+              </a:rPr>
+              <a:t>64. </a:t>
+            </a:r>
+            <a:r>
+              <a:rPr lang="en-US" sz="1300" dirty="0">
+                <a:solidFill>
+                  <a:schemeClr val="tx1"/>
+                </a:solidFill>
+              </a:rPr>
+              <a:t>Weismueller, J., Harrigan, P., Wang, S., &amp; Soutar, G. N. (2020). Influencer endorsements: How advertising disclosure and source credibility affect consumer purchase intention on social media. Australasian Marketing Journal, 28(4), 160–170.</a:t>
+            </a:r>
+            <a:endParaRPr lang="en-US" sz="1300" dirty="0"/>
+          </a:p>
+          <a:p>
+            <a:pPr indent="0" marL="0">
+              <a:spcAft>
+                <a:spcPts val="600"/>
+              </a:spcAft>
+              <a:buNone/>
+            </a:pPr>
+            <a:r>
+              <a:rPr lang="en-US" sz="1300" b="1" dirty="0">
+                <a:solidFill>
+                  <a:schemeClr val="accent4"/>
+                </a:solidFill>
+              </a:rPr>
+              <a:t>65. </a:t>
+            </a:r>
+            <a:r>
+              <a:rPr lang="en-US" sz="1300" dirty="0">
+                <a:solidFill>
+                  <a:schemeClr val="tx1"/>
+                </a:solidFill>
+              </a:rPr>
+              <a:t>Yoo, J. W., Park, J., &amp; Park, H. (2025). How can I trust you if you're fake? Understanding human-like virtual influencer credibility and the role of textual social cues. Journal of Research in Interactive Marketing, 19(4), 730–748.</a:t>
+            </a:r>
+            <a:endParaRPr lang="en-US" sz="1300" dirty="0"/>
+          </a:p>
+          <a:p>
+            <a:pPr indent="0" marL="0">
+              <a:spcAft>
+                <a:spcPts val="600"/>
+              </a:spcAft>
+              <a:buNone/>
+            </a:pPr>
+            <a:r>
+              <a:rPr lang="en-US" sz="1300" b="1" dirty="0">
+                <a:solidFill>
+                  <a:schemeClr val="accent4"/>
+                </a:solidFill>
+              </a:rPr>
+              <a:t>66. </a:t>
+            </a:r>
+            <a:r>
+              <a:rPr lang="en-US" sz="1300" dirty="0">
+                <a:solidFill>
+                  <a:schemeClr val="tx1"/>
+                </a:solidFill>
+              </a:rPr>
+              <a:t>Yuan, S., &amp; Lou, C. (2020). How social media influencers foster relationships with followers: The roles of source credibility and fairness in parasocial relationship and product interest. Journal of Interactive Advertising, 20(2), 133–147.</a:t>
+            </a:r>
+            <a:endParaRPr lang="en-US" sz="1300" dirty="0"/>
+          </a:p>
+        </p:txBody>
+      </p:sp>
+      <p:sp>
+        <p:nvSpPr>
+          <p:cNvPr id="4" name="Text 2"/>
+          <p:cNvSpPr txBox="1"/>
+          <p:nvPr/>
+        </p:nvSpPr>
+        <p:spPr>
+          <a:xfrm>
+            <a:off x="6227064" y="1645920"/>
+            <a:ext cx="5413248" cy="4754880"/>
+          </a:xfrm>
+          <a:prstGeom prst="rect">
+            <a:avLst/>
+          </a:prstGeom>
+          <a:noFill/>
+          <a:ln/>
+        </p:spPr>
+        <p:txBody>
+          <a:bodyPr wrap="square" lIns="0" tIns="0" rIns="0" bIns="0" rtlCol="0" anchor="t"/>
+          <a:lstStyle/>
+          <a:p>
+            <a:pPr indent="0" marL="0">
+              <a:spcAft>
+                <a:spcPts val="600"/>
+              </a:spcAft>
+              <a:buNone/>
+            </a:pPr>
+            <a:r>
+              <a:rPr lang="en-US" sz="1300" b="1" dirty="0">
+                <a:solidFill>
+                  <a:schemeClr val="accent4"/>
+                </a:solidFill>
+              </a:rPr>
+              <a:t>67. </a:t>
+            </a:r>
+            <a:r>
+              <a:rPr lang="en-US" sz="1300" dirty="0">
+                <a:solidFill>
+                  <a:schemeClr val="tx1"/>
+                </a:solidFill>
+              </a:rPr>
+              <a:t>Zhou, X., Yan, X., &amp; Jiang, Y. (2024). Making sense? The sensory-specific nature of virtual influencer effectiveness. Journal of Marketing, 88(4), 84–106.</a:t>
+            </a:r>
+            <a:endParaRPr lang="en-US" sz="1300" dirty="0"/>
+          </a:p>
+        </p:txBody>
+      </p:sp>
+      <p:sp>
+        <p:nvSpPr>
+          <p:cNvPr id="25" name="Slide Number Placeholder 0"/>
+          <p:cNvSpPr>
+            <a:spLocks noGrp="1"/>
+          </p:cNvSpPr>
+          <p:nvPr>
+            <p:ph type="sldNum" sz="quarter" idx="4294967295"/>
+          </p:nvPr>
+        </p:nvSpPr>
+        <p:spPr>
+          <a:xfrm>
+            <a:off x="11155680" y="6400800"/>
+            <a:ext cx="548640" cy="274320"/>
+          </a:xfrm>
+          <a:prstGeom prst="rect">
+            <a:avLst/>
+          </a:prstGeom>
+          <a:extLst>
+            <a:ext uri="{C572A759-6A51-4108-AA02-DFA0A04FC94B}">
+              <ma14:wrappingTextBoxFlag xmlns:ma14="http://schemas.microsoft.com/office/mac/drawingml/2011/main" val="0"/>
+            </a:ext>
+          </a:extLst>
+        </p:spPr>
+        <p:txBody>
+          <a:bodyPr/>
+          <a:lstStyle>
+            <a:lvl1pPr>
+              <a:defRPr sz="1200">
+                <a:solidFill>
+                  <a:schemeClr val="accent3"/>
+                </a:solidFill>
+              </a:defRPr>
+            </a:lvl1pPr>
+          </a:lstStyle>
+          <a:p>
+            <a:pPr algn="r"/>
+            <a:fld id="{F7021451-1387-4CA6-816F-3879F97B5CBC}" type="slidenum">
+              <a:rPr b="0" lang="en-US"/>
+              <a:t>24</a:t>
+            </a:fld>
+            <a:endParaRPr lang="en-US"/>
+          </a:p>
+        </p:txBody>
+      </p:sp>
+    </p:spTree>
+  </p:cSld>
+  <p:clrMapOvr>
+    <a:masterClrMapping/>
+  </p:clrMapOvr>
+</p:sld>
+</file>
+
+<file path=ppt/slides/slide25.xml><?xml version="1.0" encoding="utf-8"?>
+<p:sld xmlns:a="http://schemas.openxmlformats.org/drawingml/2006/main" xmlns:r="http://schemas.openxmlformats.org/officeDocument/2006/relationships" xmlns:p="http://schemas.openxmlformats.org/presentationml/2006/main">
+  <p:cSld name="Slide 25">
     <p:spTree>
       <p:nvGrpSpPr>
         <p:cNvPr id="1" name=""/>

</xml_diff>